<commit_message>
style(template): 修改 PPT 模板字體
</commit_message>
<xml_diff>
--- a/經文範本.pptx
+++ b/經文範本.pptx
@@ -63,10 +63,10 @@
         </a:solidFill>
         <a:effectLst/>
         <a:uFillTx/>
-        <a:latin typeface="+mj-lt"/>
-        <a:ea typeface="+mj-ea"/>
-        <a:cs typeface="+mj-cs"/>
-        <a:sym typeface="Arial"/>
+        <a:latin typeface="+mn-lt"/>
+        <a:ea typeface="+mn-ea"/>
+        <a:cs typeface="+mn-cs"/>
+        <a:sym typeface="Helvetica"/>
       </a:defRPr>
     </a:lvl1pPr>
     <a:lvl2pPr marL="0" marR="0" indent="0" algn="l" defTabSz="914400" rtl="0" fontAlgn="auto" latinLnBrk="0" hangingPunct="0">
@@ -93,10 +93,10 @@
         </a:solidFill>
         <a:effectLst/>
         <a:uFillTx/>
-        <a:latin typeface="+mj-lt"/>
-        <a:ea typeface="+mj-ea"/>
-        <a:cs typeface="+mj-cs"/>
-        <a:sym typeface="Arial"/>
+        <a:latin typeface="+mn-lt"/>
+        <a:ea typeface="+mn-ea"/>
+        <a:cs typeface="+mn-cs"/>
+        <a:sym typeface="Helvetica"/>
       </a:defRPr>
     </a:lvl2pPr>
     <a:lvl3pPr marL="0" marR="0" indent="0" algn="l" defTabSz="914400" rtl="0" fontAlgn="auto" latinLnBrk="0" hangingPunct="0">
@@ -123,10 +123,10 @@
         </a:solidFill>
         <a:effectLst/>
         <a:uFillTx/>
-        <a:latin typeface="+mj-lt"/>
-        <a:ea typeface="+mj-ea"/>
-        <a:cs typeface="+mj-cs"/>
-        <a:sym typeface="Arial"/>
+        <a:latin typeface="+mn-lt"/>
+        <a:ea typeface="+mn-ea"/>
+        <a:cs typeface="+mn-cs"/>
+        <a:sym typeface="Helvetica"/>
       </a:defRPr>
     </a:lvl3pPr>
     <a:lvl4pPr marL="0" marR="0" indent="0" algn="l" defTabSz="914400" rtl="0" fontAlgn="auto" latinLnBrk="0" hangingPunct="0">
@@ -153,10 +153,10 @@
         </a:solidFill>
         <a:effectLst/>
         <a:uFillTx/>
-        <a:latin typeface="+mj-lt"/>
-        <a:ea typeface="+mj-ea"/>
-        <a:cs typeface="+mj-cs"/>
-        <a:sym typeface="Arial"/>
+        <a:latin typeface="+mn-lt"/>
+        <a:ea typeface="+mn-ea"/>
+        <a:cs typeface="+mn-cs"/>
+        <a:sym typeface="Helvetica"/>
       </a:defRPr>
     </a:lvl4pPr>
     <a:lvl5pPr marL="0" marR="0" indent="0" algn="l" defTabSz="914400" rtl="0" fontAlgn="auto" latinLnBrk="0" hangingPunct="0">
@@ -183,10 +183,10 @@
         </a:solidFill>
         <a:effectLst/>
         <a:uFillTx/>
-        <a:latin typeface="+mj-lt"/>
-        <a:ea typeface="+mj-ea"/>
-        <a:cs typeface="+mj-cs"/>
-        <a:sym typeface="Arial"/>
+        <a:latin typeface="+mn-lt"/>
+        <a:ea typeface="+mn-ea"/>
+        <a:cs typeface="+mn-cs"/>
+        <a:sym typeface="Helvetica"/>
       </a:defRPr>
     </a:lvl5pPr>
     <a:lvl6pPr marL="0" marR="0" indent="0" algn="l" defTabSz="914400" rtl="0" fontAlgn="auto" latinLnBrk="0" hangingPunct="0">
@@ -213,10 +213,10 @@
         </a:solidFill>
         <a:effectLst/>
         <a:uFillTx/>
-        <a:latin typeface="+mj-lt"/>
-        <a:ea typeface="+mj-ea"/>
-        <a:cs typeface="+mj-cs"/>
-        <a:sym typeface="Arial"/>
+        <a:latin typeface="+mn-lt"/>
+        <a:ea typeface="+mn-ea"/>
+        <a:cs typeface="+mn-cs"/>
+        <a:sym typeface="Helvetica"/>
       </a:defRPr>
     </a:lvl6pPr>
     <a:lvl7pPr marL="0" marR="0" indent="0" algn="l" defTabSz="914400" rtl="0" fontAlgn="auto" latinLnBrk="0" hangingPunct="0">
@@ -243,10 +243,10 @@
         </a:solidFill>
         <a:effectLst/>
         <a:uFillTx/>
-        <a:latin typeface="+mj-lt"/>
-        <a:ea typeface="+mj-ea"/>
-        <a:cs typeface="+mj-cs"/>
-        <a:sym typeface="Arial"/>
+        <a:latin typeface="+mn-lt"/>
+        <a:ea typeface="+mn-ea"/>
+        <a:cs typeface="+mn-cs"/>
+        <a:sym typeface="Helvetica"/>
       </a:defRPr>
     </a:lvl7pPr>
     <a:lvl8pPr marL="0" marR="0" indent="0" algn="l" defTabSz="914400" rtl="0" fontAlgn="auto" latinLnBrk="0" hangingPunct="0">
@@ -273,10 +273,10 @@
         </a:solidFill>
         <a:effectLst/>
         <a:uFillTx/>
-        <a:latin typeface="+mj-lt"/>
-        <a:ea typeface="+mj-ea"/>
-        <a:cs typeface="+mj-cs"/>
-        <a:sym typeface="Arial"/>
+        <a:latin typeface="+mn-lt"/>
+        <a:ea typeface="+mn-ea"/>
+        <a:cs typeface="+mn-cs"/>
+        <a:sym typeface="Helvetica"/>
       </a:defRPr>
     </a:lvl8pPr>
     <a:lvl9pPr marL="0" marR="0" indent="0" algn="l" defTabSz="914400" rtl="0" fontAlgn="auto" latinLnBrk="0" hangingPunct="0">
@@ -303,10 +303,10 @@
         </a:solidFill>
         <a:effectLst/>
         <a:uFillTx/>
-        <a:latin typeface="+mj-lt"/>
-        <a:ea typeface="+mj-ea"/>
-        <a:cs typeface="+mj-cs"/>
-        <a:sym typeface="Arial"/>
+        <a:latin typeface="+mn-lt"/>
+        <a:ea typeface="+mn-ea"/>
+        <a:cs typeface="+mn-cs"/>
+        <a:sym typeface="Helvetica"/>
       </a:defRPr>
     </a:lvl9pPr>
   </p:defaultTextStyle>
@@ -509,6 +509,9 @@
           <a:bodyPr anchor="t"/>
           <a:lstStyle>
             <a:lvl1pPr algn="ctr">
+              <a:lnSpc>
+                <a:spcPct val="100000"/>
+              </a:lnSpc>
               <a:defRPr sz="6600">
                 <a:solidFill>
                   <a:srgbClr val="FFFF00"/>
@@ -542,18 +545,16 @@
           </a:prstGeom>
         </p:spPr>
         <p:txBody>
-          <a:bodyPr lIns="45699" tIns="45699" rIns="45699" bIns="45699">
-            <a:normAutofit fontScale="100000" lnSpcReduction="0"/>
-          </a:bodyPr>
+          <a:bodyPr/>
           <a:lstStyle>
-            <a:lvl1pPr marL="228600" algn="ctr">
+            <a:lvl1pPr algn="ctr">
               <a:lnSpc>
                 <a:spcPct val="90000"/>
               </a:lnSpc>
               <a:spcBef>
                 <a:spcPts val="1000"/>
               </a:spcBef>
-              <a:defRPr b="1" sz="100">
+              <a:defRPr sz="100">
                 <a:solidFill>
                   <a:srgbClr val="FFE389"/>
                 </a:solidFill>
@@ -568,7 +569,7 @@
               </a:spcBef>
               <a:buSzPts val="100"/>
               <a:buChar char="•"/>
-              <a:defRPr b="1" sz="100">
+              <a:defRPr sz="100">
                 <a:solidFill>
                   <a:srgbClr val="FFE389"/>
                 </a:solidFill>
@@ -583,7 +584,7 @@
               </a:spcBef>
               <a:buSzPts val="100"/>
               <a:buChar char="•"/>
-              <a:defRPr b="1" sz="100">
+              <a:defRPr sz="100">
                 <a:solidFill>
                   <a:srgbClr val="FFE389"/>
                 </a:solidFill>
@@ -598,7 +599,7 @@
               </a:spcBef>
               <a:buSzPts val="100"/>
               <a:buChar char="•"/>
-              <a:defRPr b="1" sz="100">
+              <a:defRPr sz="100">
                 <a:solidFill>
                   <a:srgbClr val="FFE389"/>
                 </a:solidFill>
@@ -613,7 +614,7 @@
               </a:spcBef>
               <a:buSzPts val="100"/>
               <a:buChar char="•"/>
-              <a:defRPr b="1" sz="100">
+              <a:defRPr sz="100">
                 <a:solidFill>
                   <a:srgbClr val="FFE389"/>
                 </a:solidFill>
@@ -725,40 +726,38 @@
           </a:prstGeom>
         </p:spPr>
         <p:txBody>
-          <a:bodyPr lIns="45699" tIns="45699" rIns="45699" bIns="45699">
-            <a:normAutofit fontScale="100000" lnSpcReduction="0"/>
-          </a:bodyPr>
+          <a:bodyPr/>
           <a:lstStyle>
-            <a:lvl1pPr algn="ctr">
-              <a:defRPr b="1" sz="4800">
+            <a:lvl1pPr indent="0" algn="ctr">
+              <a:defRPr sz="4800">
                 <a:solidFill>
                   <a:srgbClr val="FFFFFF"/>
                 </a:solidFill>
               </a:defRPr>
             </a:lvl1pPr>
-            <a:lvl2pPr algn="ctr">
-              <a:defRPr b="1" sz="4800">
+            <a:lvl2pPr indent="0" algn="ctr">
+              <a:defRPr sz="4800">
                 <a:solidFill>
                   <a:srgbClr val="FFFFFF"/>
                 </a:solidFill>
               </a:defRPr>
             </a:lvl2pPr>
-            <a:lvl3pPr algn="ctr">
-              <a:defRPr b="1" sz="4800">
+            <a:lvl3pPr indent="0" algn="ctr">
+              <a:defRPr sz="4800">
                 <a:solidFill>
                   <a:srgbClr val="FFFFFF"/>
                 </a:solidFill>
               </a:defRPr>
             </a:lvl3pPr>
-            <a:lvl4pPr algn="ctr">
-              <a:defRPr b="1" sz="4800">
+            <a:lvl4pPr indent="0" algn="ctr">
+              <a:defRPr sz="4800">
                 <a:solidFill>
                   <a:srgbClr val="FFFFFF"/>
                 </a:solidFill>
               </a:defRPr>
             </a:lvl4pPr>
-            <a:lvl5pPr algn="ctr">
-              <a:defRPr b="1" sz="4800">
+            <a:lvl5pPr indent="0" algn="ctr">
+              <a:defRPr sz="4800">
                 <a:solidFill>
                   <a:srgbClr val="FFFFFF"/>
                 </a:solidFill>
@@ -808,7 +807,7 @@
         <p:spPr>
           <a:xfrm>
             <a:off x="2999656" y="1988840"/>
-            <a:ext cx="9090745" cy="936105"/>
+            <a:ext cx="9090746" cy="936106"/>
           </a:xfrm>
           <a:prstGeom prst="rect">
             <a:avLst/>
@@ -854,15 +853,13 @@
           </a:prstGeom>
         </p:spPr>
         <p:txBody>
-          <a:bodyPr lIns="45699" tIns="45699" rIns="45699" bIns="45699">
-            <a:normAutofit fontScale="100000" lnSpcReduction="0"/>
-          </a:bodyPr>
+          <a:bodyPr/>
           <a:lstStyle/>
           <a:p>
-            <a:pPr marL="228600" algn="ctr">
-              <a:defRPr b="1" sz="3200">
+            <a:pPr indent="0">
+              <a:defRPr b="0" sz="1400">
                 <a:solidFill>
-                  <a:srgbClr val="FFFF00"/>
+                  <a:srgbClr val="000000"/>
                 </a:solidFill>
               </a:defRPr>
             </a:pPr>
@@ -926,13 +923,28 @@
           </p:nvPr>
         </p:nvSpPr>
         <p:spPr>
+          <a:xfrm>
+            <a:off x="838200" y="365125"/>
+            <a:ext cx="10515600" cy="1325563"/>
+          </a:xfrm>
           <a:prstGeom prst="rect">
             <a:avLst/>
           </a:prstGeom>
         </p:spPr>
         <p:txBody>
           <a:bodyPr/>
-          <a:lstStyle/>
+          <a:lstStyle>
+            <a:lvl1pPr>
+              <a:lnSpc>
+                <a:spcPct val="100000"/>
+              </a:lnSpc>
+              <a:defRPr>
+                <a:solidFill>
+                  <a:srgbClr val="FFFFFF"/>
+                </a:solidFill>
+              </a:defRPr>
+            </a:lvl1pPr>
+          </a:lstStyle>
           <a:p>
             <a:pPr/>
             <a:r>
@@ -1000,47 +1012,45 @@
         <p:spPr>
           <a:xfrm>
             <a:off x="191344" y="1124744"/>
-            <a:ext cx="1091664" cy="1910969"/>
+            <a:ext cx="1091664" cy="1910970"/>
           </a:xfrm>
           <a:prstGeom prst="rect">
             <a:avLst/>
           </a:prstGeom>
         </p:spPr>
         <p:txBody>
-          <a:bodyPr lIns="45699" tIns="45699" rIns="45699" bIns="45699">
-            <a:normAutofit fontScale="100000" lnSpcReduction="0"/>
-          </a:bodyPr>
+          <a:bodyPr/>
           <a:lstStyle>
-            <a:lvl1pPr marL="228600" algn="ctr">
-              <a:defRPr b="1" baseline="30000" sz="5400">
+            <a:lvl1pPr algn="ctr">
+              <a:defRPr baseline="30000">
                 <a:solidFill>
                   <a:srgbClr val="FFFF00"/>
                 </a:solidFill>
               </a:defRPr>
             </a:lvl1pPr>
-            <a:lvl2pPr marL="228600" indent="457200" algn="ctr">
-              <a:defRPr b="1" baseline="30000" sz="5400">
+            <a:lvl2pPr algn="ctr">
+              <a:defRPr baseline="30000">
                 <a:solidFill>
                   <a:srgbClr val="FFFF00"/>
                 </a:solidFill>
               </a:defRPr>
             </a:lvl2pPr>
-            <a:lvl3pPr marL="228600" indent="914400" algn="ctr">
-              <a:defRPr b="1" baseline="30000" sz="5400">
+            <a:lvl3pPr algn="ctr">
+              <a:defRPr baseline="30000">
                 <a:solidFill>
                   <a:srgbClr val="FFFF00"/>
                 </a:solidFill>
               </a:defRPr>
             </a:lvl3pPr>
-            <a:lvl4pPr marL="228600" indent="1371600" algn="ctr">
-              <a:defRPr b="1" baseline="30000" sz="5400">
+            <a:lvl4pPr algn="ctr">
+              <a:defRPr baseline="30000">
                 <a:solidFill>
                   <a:srgbClr val="FFFF00"/>
                 </a:solidFill>
               </a:defRPr>
             </a:lvl4pPr>
-            <a:lvl5pPr marL="228600" indent="1828800" algn="ctr">
-              <a:defRPr b="1" baseline="30000" sz="5400">
+            <a:lvl5pPr algn="ctr">
+              <a:defRPr baseline="30000">
                 <a:solidFill>
                   <a:srgbClr val="FFFF00"/>
                 </a:solidFill>
@@ -1089,8 +1099,8 @@
         </p:nvSpPr>
         <p:spPr>
           <a:xfrm>
-            <a:off x="191344" y="-1692"/>
-            <a:ext cx="11593288" cy="937980"/>
+            <a:off x="191344" y="-1693"/>
+            <a:ext cx="11593288" cy="937981"/>
           </a:xfrm>
           <a:prstGeom prst="rect">
             <a:avLst/>
@@ -1100,6 +1110,9 @@
           <a:bodyPr anchor="b"/>
           <a:lstStyle>
             <a:lvl1pPr>
+              <a:lnSpc>
+                <a:spcPct val="100000"/>
+              </a:lnSpc>
               <a:defRPr sz="5400">
                 <a:solidFill>
                   <a:srgbClr val="FFFF00"/>
@@ -1133,15 +1146,13 @@
           </a:prstGeom>
         </p:spPr>
         <p:txBody>
-          <a:bodyPr lIns="45699" tIns="45699" rIns="45699" bIns="45699">
-            <a:normAutofit fontScale="100000" lnSpcReduction="0"/>
-          </a:bodyPr>
+          <a:bodyPr/>
           <a:lstStyle/>
           <a:p>
-            <a:pPr marL="228600">
-              <a:defRPr b="1" sz="5400">
+            <a:pPr indent="0">
+              <a:defRPr b="0" sz="1400">
                 <a:solidFill>
-                  <a:srgbClr val="FFFFFF"/>
+                  <a:srgbClr val="000000"/>
                 </a:solidFill>
               </a:defRPr>
             </a:pPr>
@@ -1158,23 +1169,21 @@
         </p:nvSpPr>
         <p:spPr>
           <a:xfrm>
-            <a:off x="983432" y="6079950"/>
-            <a:ext cx="7416825" cy="733426"/>
+            <a:off x="983432" y="6079949"/>
+            <a:ext cx="7416825" cy="733427"/>
           </a:xfrm>
           <a:prstGeom prst="rect">
             <a:avLst/>
           </a:prstGeom>
         </p:spPr>
         <p:txBody>
-          <a:bodyPr lIns="45699" tIns="45699" rIns="45699" bIns="45699">
-            <a:normAutofit fontScale="100000" lnSpcReduction="0"/>
-          </a:bodyPr>
+          <a:bodyPr/>
           <a:lstStyle/>
           <a:p>
-            <a:pPr marL="228600">
-              <a:defRPr b="1" sz="4000">
+            <a:pPr indent="0">
+              <a:defRPr b="0" sz="1400">
                 <a:solidFill>
-                  <a:srgbClr val="FBE4D4"/>
+                  <a:srgbClr val="000000"/>
                 </a:solidFill>
               </a:defRPr>
             </a:pPr>
@@ -1238,28 +1247,13 @@
           </p:nvPr>
         </p:nvSpPr>
         <p:spPr>
-          <a:xfrm>
-            <a:off x="479376" y="44625"/>
-            <a:ext cx="11233248" cy="864096"/>
-          </a:xfrm>
           <a:prstGeom prst="rect">
             <a:avLst/>
           </a:prstGeom>
         </p:spPr>
         <p:txBody>
           <a:bodyPr/>
-          <a:lstStyle>
-            <a:lvl1pPr>
-              <a:lnSpc>
-                <a:spcPct val="110000"/>
-              </a:lnSpc>
-              <a:defRPr>
-                <a:solidFill>
-                  <a:srgbClr val="FF6161"/>
-                </a:solidFill>
-              </a:defRPr>
-            </a:lvl1pPr>
-          </a:lstStyle>
+          <a:lstStyle/>
           <a:p>
             <a:pPr/>
             <a:r>
@@ -1277,55 +1271,13 @@
           </p:nvPr>
         </p:nvSpPr>
         <p:spPr>
-          <a:xfrm>
-            <a:off x="479376" y="908720"/>
-            <a:ext cx="11233248" cy="5949280"/>
-          </a:xfrm>
           <a:prstGeom prst="rect">
             <a:avLst/>
           </a:prstGeom>
         </p:spPr>
         <p:txBody>
-          <a:bodyPr lIns="45699" tIns="45699" rIns="45699" bIns="45699">
-            <a:normAutofit fontScale="100000" lnSpcReduction="0"/>
-          </a:bodyPr>
-          <a:lstStyle>
-            <a:lvl1pPr marL="228600">
-              <a:defRPr b="1" sz="5400">
-                <a:solidFill>
-                  <a:srgbClr val="FFF2CC"/>
-                </a:solidFill>
-              </a:defRPr>
-            </a:lvl1pPr>
-            <a:lvl2pPr marL="228600" indent="457200">
-              <a:defRPr b="1" sz="5400">
-                <a:solidFill>
-                  <a:srgbClr val="FFF2CC"/>
-                </a:solidFill>
-              </a:defRPr>
-            </a:lvl2pPr>
-            <a:lvl3pPr marL="228600" indent="914400">
-              <a:defRPr b="1" sz="5400">
-                <a:solidFill>
-                  <a:srgbClr val="FFF2CC"/>
-                </a:solidFill>
-              </a:defRPr>
-            </a:lvl3pPr>
-            <a:lvl4pPr marL="228600" indent="1371600">
-              <a:defRPr b="1" sz="5400">
-                <a:solidFill>
-                  <a:srgbClr val="FFF2CC"/>
-                </a:solidFill>
-              </a:defRPr>
-            </a:lvl4pPr>
-            <a:lvl5pPr marL="228600" indent="1828800">
-              <a:defRPr b="1" sz="5400">
-                <a:solidFill>
-                  <a:srgbClr val="FFF2CC"/>
-                </a:solidFill>
-              </a:defRPr>
-            </a:lvl5pPr>
-          </a:lstStyle>
+          <a:bodyPr/>
+          <a:lstStyle/>
           <a:p>
             <a:pPr/>
             <a:r>
@@ -1417,7 +1369,7 @@
         <p:spPr>
           <a:xfrm>
             <a:off x="623391" y="548679"/>
-            <a:ext cx="10945217" cy="2952329"/>
+            <a:ext cx="10945218" cy="2952330"/>
           </a:xfrm>
           <a:prstGeom prst="rect">
             <a:avLst/>
@@ -1427,7 +1379,14 @@
           <a:bodyPr/>
           <a:lstStyle>
             <a:lvl1pPr algn="ctr">
-              <a:defRPr sz="8800"/>
+              <a:lnSpc>
+                <a:spcPct val="100000"/>
+              </a:lnSpc>
+              <a:defRPr sz="8800">
+                <a:solidFill>
+                  <a:srgbClr val="FFFFFF"/>
+                </a:solidFill>
+              </a:defRPr>
             </a:lvl1pPr>
           </a:lstStyle>
           <a:p>
@@ -1449,62 +1408,60 @@
         <p:spPr>
           <a:xfrm>
             <a:off x="2999656" y="3861046"/>
-            <a:ext cx="7884369" cy="2852738"/>
+            <a:ext cx="7884370" cy="2852739"/>
           </a:xfrm>
           <a:prstGeom prst="rect">
             <a:avLst/>
           </a:prstGeom>
         </p:spPr>
         <p:txBody>
-          <a:bodyPr lIns="45699" tIns="45699" rIns="45699" bIns="45699">
-            <a:normAutofit fontScale="100000" lnSpcReduction="0"/>
-          </a:bodyPr>
+          <a:bodyPr/>
           <a:lstStyle>
-            <a:lvl1pPr marL="228600">
+            <a:lvl1pPr>
               <a:lnSpc>
                 <a:spcPct val="110000"/>
               </a:lnSpc>
-              <a:defRPr b="1" sz="4000">
+              <a:defRPr sz="4000">
                 <a:solidFill>
                   <a:srgbClr val="FFFFFF"/>
                 </a:solidFill>
               </a:defRPr>
             </a:lvl1pPr>
-            <a:lvl2pPr marL="228600" indent="457200">
+            <a:lvl2pPr>
               <a:lnSpc>
                 <a:spcPct val="110000"/>
               </a:lnSpc>
-              <a:defRPr b="1" sz="4000">
+              <a:defRPr sz="4000">
                 <a:solidFill>
                   <a:srgbClr val="FFFFFF"/>
                 </a:solidFill>
               </a:defRPr>
             </a:lvl2pPr>
-            <a:lvl3pPr marL="228600" indent="914400">
+            <a:lvl3pPr>
               <a:lnSpc>
                 <a:spcPct val="110000"/>
               </a:lnSpc>
-              <a:defRPr b="1" sz="4000">
+              <a:defRPr sz="4000">
                 <a:solidFill>
                   <a:srgbClr val="FFFFFF"/>
                 </a:solidFill>
               </a:defRPr>
             </a:lvl3pPr>
-            <a:lvl4pPr marL="228600" indent="1371600">
+            <a:lvl4pPr>
               <a:lnSpc>
                 <a:spcPct val="110000"/>
               </a:lnSpc>
-              <a:defRPr b="1" sz="4000">
+              <a:defRPr sz="4000">
                 <a:solidFill>
                   <a:srgbClr val="FFFFFF"/>
                 </a:solidFill>
               </a:defRPr>
             </a:lvl4pPr>
-            <a:lvl5pPr marL="228600" indent="1828800">
+            <a:lvl5pPr>
               <a:lnSpc>
                 <a:spcPct val="110000"/>
               </a:lnSpc>
-              <a:defRPr b="1" sz="4000">
+              <a:defRPr sz="4000">
                 <a:solidFill>
                   <a:srgbClr val="FFFFFF"/>
                 </a:solidFill>
@@ -1551,8 +1508,8 @@
         </p:nvSpPr>
         <p:spPr>
           <a:xfrm>
-            <a:off x="1389196" y="3861047"/>
-            <a:ext cx="1492727" cy="3149562"/>
+            <a:off x="1389196" y="3861046"/>
+            <a:ext cx="1492728" cy="3149559"/>
           </a:xfrm>
           <a:prstGeom prst="rect">
             <a:avLst/>
@@ -1580,6 +1537,10 @@
                 <a:solidFill>
                   <a:srgbClr val="FFFFFF"/>
                 </a:solidFill>
+                <a:latin typeface="+mj-lt"/>
+                <a:ea typeface="+mj-ea"/>
+                <a:cs typeface="+mj-cs"/>
+                <a:sym typeface="Arial"/>
               </a:defRPr>
             </a:pPr>
             <a:r>
@@ -1595,6 +1556,10 @@
                 <a:solidFill>
                   <a:srgbClr val="FFFFFF"/>
                 </a:solidFill>
+                <a:latin typeface="+mj-lt"/>
+                <a:ea typeface="+mj-ea"/>
+                <a:cs typeface="+mj-cs"/>
+                <a:sym typeface="Arial"/>
               </a:defRPr>
             </a:pPr>
             <a:r>
@@ -1668,8 +1633,8 @@
         </p:nvSpPr>
         <p:spPr>
           <a:xfrm>
-            <a:off x="838200" y="365125"/>
-            <a:ext cx="10515600" cy="1325563"/>
+            <a:off x="479376" y="44625"/>
+            <a:ext cx="11233248" cy="864096"/>
           </a:xfrm>
           <a:prstGeom prst="rect">
             <a:avLst/>
@@ -1706,8 +1671,8 @@
         </p:nvSpPr>
         <p:spPr>
           <a:xfrm>
-            <a:off x="609600" y="1600200"/>
-            <a:ext cx="10972800" cy="4525963"/>
+            <a:off x="479376" y="908720"/>
+            <a:ext cx="11233248" cy="5949280"/>
           </a:xfrm>
           <a:prstGeom prst="rect">
             <a:avLst/>
@@ -1722,7 +1687,9 @@
           </a:extLst>
         </p:spPr>
         <p:txBody>
-          <a:bodyPr lIns="45719" rIns="45719"/>
+          <a:bodyPr lIns="45699" tIns="45699" rIns="45699" bIns="45699">
+            <a:normAutofit fontScale="100000" lnSpcReduction="0"/>
+          </a:bodyPr>
           <a:lstStyle/>
           <a:p>
             <a:pPr/>
@@ -1766,8 +1733,8 @@
         </p:nvSpPr>
         <p:spPr>
           <a:xfrm>
-            <a:off x="5892800" y="6172200"/>
-            <a:ext cx="2844800" cy="368301"/>
+            <a:off x="8463946" y="6224224"/>
+            <a:ext cx="273654" cy="264253"/>
           </a:xfrm>
           <a:prstGeom prst="rect">
             <a:avLst/>
@@ -1777,12 +1744,17 @@
           </a:ln>
         </p:spPr>
         <p:txBody>
-          <a:bodyPr wrap="none" lIns="45719" rIns="45719" anchor="ctr">
+          <a:bodyPr wrap="none" lIns="45718" tIns="45718" rIns="45718" bIns="45718" anchor="ctr">
             <a:spAutoFit/>
           </a:bodyPr>
           <a:lstStyle>
             <a:lvl1pPr algn="r">
-              <a:defRPr sz="1200"/>
+              <a:defRPr sz="1200">
+                <a:latin typeface="+mj-lt"/>
+                <a:ea typeface="+mj-ea"/>
+                <a:cs typeface="+mj-cs"/>
+                <a:sym typeface="Arial"/>
+              </a:defRPr>
             </a:lvl1pPr>
           </a:lstStyle>
           <a:p>
@@ -1807,7 +1779,7 @@
     <p:titleStyle>
       <a:lvl1pPr marL="0" marR="0" indent="0" algn="l" defTabSz="914400" rtl="0" latinLnBrk="0">
         <a:lnSpc>
-          <a:spcPct val="100000"/>
+          <a:spcPct val="110000"/>
         </a:lnSpc>
         <a:spcBef>
           <a:spcPts val="0"/>
@@ -1822,7 +1794,7 @@
         <a:tabLst/>
         <a:defRPr b="1" baseline="0" cap="none" i="0" spc="0" strike="noStrike" sz="6000" u="none">
           <a:solidFill>
-            <a:srgbClr val="FFFFFF"/>
+            <a:srgbClr val="FF6161"/>
           </a:solidFill>
           <a:uFillTx/>
           <a:latin typeface="+mj-lt"/>
@@ -1833,7 +1805,7 @@
       </a:lvl1pPr>
       <a:lvl2pPr marL="0" marR="0" indent="0" algn="l" defTabSz="914400" rtl="0" latinLnBrk="0">
         <a:lnSpc>
-          <a:spcPct val="100000"/>
+          <a:spcPct val="110000"/>
         </a:lnSpc>
         <a:spcBef>
           <a:spcPts val="0"/>
@@ -1848,7 +1820,7 @@
         <a:tabLst/>
         <a:defRPr b="1" baseline="0" cap="none" i="0" spc="0" strike="noStrike" sz="6000" u="none">
           <a:solidFill>
-            <a:srgbClr val="FFFFFF"/>
+            <a:srgbClr val="FF6161"/>
           </a:solidFill>
           <a:uFillTx/>
           <a:latin typeface="+mj-lt"/>
@@ -1859,7 +1831,7 @@
       </a:lvl2pPr>
       <a:lvl3pPr marL="0" marR="0" indent="0" algn="l" defTabSz="914400" rtl="0" latinLnBrk="0">
         <a:lnSpc>
-          <a:spcPct val="100000"/>
+          <a:spcPct val="110000"/>
         </a:lnSpc>
         <a:spcBef>
           <a:spcPts val="0"/>
@@ -1874,7 +1846,7 @@
         <a:tabLst/>
         <a:defRPr b="1" baseline="0" cap="none" i="0" spc="0" strike="noStrike" sz="6000" u="none">
           <a:solidFill>
-            <a:srgbClr val="FFFFFF"/>
+            <a:srgbClr val="FF6161"/>
           </a:solidFill>
           <a:uFillTx/>
           <a:latin typeface="+mj-lt"/>
@@ -1885,7 +1857,7 @@
       </a:lvl3pPr>
       <a:lvl4pPr marL="0" marR="0" indent="0" algn="l" defTabSz="914400" rtl="0" latinLnBrk="0">
         <a:lnSpc>
-          <a:spcPct val="100000"/>
+          <a:spcPct val="110000"/>
         </a:lnSpc>
         <a:spcBef>
           <a:spcPts val="0"/>
@@ -1900,7 +1872,7 @@
         <a:tabLst/>
         <a:defRPr b="1" baseline="0" cap="none" i="0" spc="0" strike="noStrike" sz="6000" u="none">
           <a:solidFill>
-            <a:srgbClr val="FFFFFF"/>
+            <a:srgbClr val="FF6161"/>
           </a:solidFill>
           <a:uFillTx/>
           <a:latin typeface="+mj-lt"/>
@@ -1911,7 +1883,7 @@
       </a:lvl4pPr>
       <a:lvl5pPr marL="0" marR="0" indent="0" algn="l" defTabSz="914400" rtl="0" latinLnBrk="0">
         <a:lnSpc>
-          <a:spcPct val="100000"/>
+          <a:spcPct val="110000"/>
         </a:lnSpc>
         <a:spcBef>
           <a:spcPts val="0"/>
@@ -1926,7 +1898,243 @@
         <a:tabLst/>
         <a:defRPr b="1" baseline="0" cap="none" i="0" spc="0" strike="noStrike" sz="6000" u="none">
           <a:solidFill>
-            <a:srgbClr val="FFFFFF"/>
+            <a:srgbClr val="FF6161"/>
+          </a:solidFill>
+          <a:uFillTx/>
+          <a:latin typeface="+mj-lt"/>
+          <a:ea typeface="+mj-ea"/>
+          <a:cs typeface="+mj-cs"/>
+          <a:sym typeface="Arial"/>
+        </a:defRPr>
+      </a:lvl5pPr>
+      <a:lvl6pPr marL="0" marR="0" indent="0" algn="l" defTabSz="914400" rtl="0" latinLnBrk="0">
+        <a:lnSpc>
+          <a:spcPct val="110000"/>
+        </a:lnSpc>
+        <a:spcBef>
+          <a:spcPts val="0"/>
+        </a:spcBef>
+        <a:spcAft>
+          <a:spcPts val="0"/>
+        </a:spcAft>
+        <a:buClrTx/>
+        <a:buSzTx/>
+        <a:buFontTx/>
+        <a:buNone/>
+        <a:tabLst/>
+        <a:defRPr b="1" baseline="0" cap="none" i="0" spc="0" strike="noStrike" sz="6000" u="none">
+          <a:solidFill>
+            <a:srgbClr val="FF6161"/>
+          </a:solidFill>
+          <a:uFillTx/>
+          <a:latin typeface="+mj-lt"/>
+          <a:ea typeface="+mj-ea"/>
+          <a:cs typeface="+mj-cs"/>
+          <a:sym typeface="Arial"/>
+        </a:defRPr>
+      </a:lvl6pPr>
+      <a:lvl7pPr marL="0" marR="0" indent="0" algn="l" defTabSz="914400" rtl="0" latinLnBrk="0">
+        <a:lnSpc>
+          <a:spcPct val="110000"/>
+        </a:lnSpc>
+        <a:spcBef>
+          <a:spcPts val="0"/>
+        </a:spcBef>
+        <a:spcAft>
+          <a:spcPts val="0"/>
+        </a:spcAft>
+        <a:buClrTx/>
+        <a:buSzTx/>
+        <a:buFontTx/>
+        <a:buNone/>
+        <a:tabLst/>
+        <a:defRPr b="1" baseline="0" cap="none" i="0" spc="0" strike="noStrike" sz="6000" u="none">
+          <a:solidFill>
+            <a:srgbClr val="FF6161"/>
+          </a:solidFill>
+          <a:uFillTx/>
+          <a:latin typeface="+mj-lt"/>
+          <a:ea typeface="+mj-ea"/>
+          <a:cs typeface="+mj-cs"/>
+          <a:sym typeface="Arial"/>
+        </a:defRPr>
+      </a:lvl7pPr>
+      <a:lvl8pPr marL="0" marR="0" indent="0" algn="l" defTabSz="914400" rtl="0" latinLnBrk="0">
+        <a:lnSpc>
+          <a:spcPct val="110000"/>
+        </a:lnSpc>
+        <a:spcBef>
+          <a:spcPts val="0"/>
+        </a:spcBef>
+        <a:spcAft>
+          <a:spcPts val="0"/>
+        </a:spcAft>
+        <a:buClrTx/>
+        <a:buSzTx/>
+        <a:buFontTx/>
+        <a:buNone/>
+        <a:tabLst/>
+        <a:defRPr b="1" baseline="0" cap="none" i="0" spc="0" strike="noStrike" sz="6000" u="none">
+          <a:solidFill>
+            <a:srgbClr val="FF6161"/>
+          </a:solidFill>
+          <a:uFillTx/>
+          <a:latin typeface="+mj-lt"/>
+          <a:ea typeface="+mj-ea"/>
+          <a:cs typeface="+mj-cs"/>
+          <a:sym typeface="Arial"/>
+        </a:defRPr>
+      </a:lvl8pPr>
+      <a:lvl9pPr marL="0" marR="0" indent="0" algn="l" defTabSz="914400" rtl="0" latinLnBrk="0">
+        <a:lnSpc>
+          <a:spcPct val="110000"/>
+        </a:lnSpc>
+        <a:spcBef>
+          <a:spcPts val="0"/>
+        </a:spcBef>
+        <a:spcAft>
+          <a:spcPts val="0"/>
+        </a:spcAft>
+        <a:buClrTx/>
+        <a:buSzTx/>
+        <a:buFontTx/>
+        <a:buNone/>
+        <a:tabLst/>
+        <a:defRPr b="1" baseline="0" cap="none" i="0" spc="0" strike="noStrike" sz="6000" u="none">
+          <a:solidFill>
+            <a:srgbClr val="FF6161"/>
+          </a:solidFill>
+          <a:uFillTx/>
+          <a:latin typeface="+mj-lt"/>
+          <a:ea typeface="+mj-ea"/>
+          <a:cs typeface="+mj-cs"/>
+          <a:sym typeface="Arial"/>
+        </a:defRPr>
+      </a:lvl9pPr>
+    </p:titleStyle>
+    <p:bodyStyle>
+      <a:lvl1pPr marL="0" marR="0" indent="228600" algn="l" defTabSz="914400" rtl="0" latinLnBrk="0">
+        <a:lnSpc>
+          <a:spcPct val="100000"/>
+        </a:lnSpc>
+        <a:spcBef>
+          <a:spcPts val="0"/>
+        </a:spcBef>
+        <a:spcAft>
+          <a:spcPts val="0"/>
+        </a:spcAft>
+        <a:buClrTx/>
+        <a:buSzTx/>
+        <a:buFontTx/>
+        <a:buNone/>
+        <a:tabLst/>
+        <a:defRPr b="1" baseline="0" cap="none" i="0" spc="0" strike="noStrike" sz="5400" u="none">
+          <a:solidFill>
+            <a:srgbClr val="FFF2CC"/>
+          </a:solidFill>
+          <a:uFillTx/>
+          <a:latin typeface="+mj-lt"/>
+          <a:ea typeface="+mj-ea"/>
+          <a:cs typeface="+mj-cs"/>
+          <a:sym typeface="Arial"/>
+        </a:defRPr>
+      </a:lvl1pPr>
+      <a:lvl2pPr marL="0" marR="0" indent="228600" algn="l" defTabSz="914400" rtl="0" latinLnBrk="0">
+        <a:lnSpc>
+          <a:spcPct val="100000"/>
+        </a:lnSpc>
+        <a:spcBef>
+          <a:spcPts val="0"/>
+        </a:spcBef>
+        <a:spcAft>
+          <a:spcPts val="0"/>
+        </a:spcAft>
+        <a:buClrTx/>
+        <a:buSzTx/>
+        <a:buFontTx/>
+        <a:buNone/>
+        <a:tabLst/>
+        <a:defRPr b="1" baseline="0" cap="none" i="0" spc="0" strike="noStrike" sz="5400" u="none">
+          <a:solidFill>
+            <a:srgbClr val="FFF2CC"/>
+          </a:solidFill>
+          <a:uFillTx/>
+          <a:latin typeface="+mj-lt"/>
+          <a:ea typeface="+mj-ea"/>
+          <a:cs typeface="+mj-cs"/>
+          <a:sym typeface="Arial"/>
+        </a:defRPr>
+      </a:lvl2pPr>
+      <a:lvl3pPr marL="0" marR="0" indent="228600" algn="l" defTabSz="914400" rtl="0" latinLnBrk="0">
+        <a:lnSpc>
+          <a:spcPct val="100000"/>
+        </a:lnSpc>
+        <a:spcBef>
+          <a:spcPts val="0"/>
+        </a:spcBef>
+        <a:spcAft>
+          <a:spcPts val="0"/>
+        </a:spcAft>
+        <a:buClrTx/>
+        <a:buSzTx/>
+        <a:buFontTx/>
+        <a:buNone/>
+        <a:tabLst/>
+        <a:defRPr b="1" baseline="0" cap="none" i="0" spc="0" strike="noStrike" sz="5400" u="none">
+          <a:solidFill>
+            <a:srgbClr val="FFF2CC"/>
+          </a:solidFill>
+          <a:uFillTx/>
+          <a:latin typeface="+mj-lt"/>
+          <a:ea typeface="+mj-ea"/>
+          <a:cs typeface="+mj-cs"/>
+          <a:sym typeface="Arial"/>
+        </a:defRPr>
+      </a:lvl3pPr>
+      <a:lvl4pPr marL="0" marR="0" indent="228600" algn="l" defTabSz="914400" rtl="0" latinLnBrk="0">
+        <a:lnSpc>
+          <a:spcPct val="100000"/>
+        </a:lnSpc>
+        <a:spcBef>
+          <a:spcPts val="0"/>
+        </a:spcBef>
+        <a:spcAft>
+          <a:spcPts val="0"/>
+        </a:spcAft>
+        <a:buClrTx/>
+        <a:buSzTx/>
+        <a:buFontTx/>
+        <a:buNone/>
+        <a:tabLst/>
+        <a:defRPr b="1" baseline="0" cap="none" i="0" spc="0" strike="noStrike" sz="5400" u="none">
+          <a:solidFill>
+            <a:srgbClr val="FFF2CC"/>
+          </a:solidFill>
+          <a:uFillTx/>
+          <a:latin typeface="+mj-lt"/>
+          <a:ea typeface="+mj-ea"/>
+          <a:cs typeface="+mj-cs"/>
+          <a:sym typeface="Arial"/>
+        </a:defRPr>
+      </a:lvl4pPr>
+      <a:lvl5pPr marL="0" marR="0" indent="228600" algn="l" defTabSz="914400" rtl="0" latinLnBrk="0">
+        <a:lnSpc>
+          <a:spcPct val="100000"/>
+        </a:lnSpc>
+        <a:spcBef>
+          <a:spcPts val="0"/>
+        </a:spcBef>
+        <a:spcAft>
+          <a:spcPts val="0"/>
+        </a:spcAft>
+        <a:buClrTx/>
+        <a:buSzTx/>
+        <a:buFontTx/>
+        <a:buNone/>
+        <a:tabLst/>
+        <a:defRPr b="1" baseline="0" cap="none" i="0" spc="0" strike="noStrike" sz="5400" u="none">
+          <a:solidFill>
+            <a:srgbClr val="FFF2CC"/>
           </a:solidFill>
           <a:uFillTx/>
           <a:latin typeface="+mj-lt"/>
@@ -1950,9 +2158,9 @@
         <a:buFontTx/>
         <a:buNone/>
         <a:tabLst/>
-        <a:defRPr b="1" baseline="0" cap="none" i="0" spc="0" strike="noStrike" sz="6000" u="none">
+        <a:defRPr b="1" baseline="0" cap="none" i="0" spc="0" strike="noStrike" sz="5400" u="none">
           <a:solidFill>
-            <a:srgbClr val="FFFFFF"/>
+            <a:srgbClr val="FFF2CC"/>
           </a:solidFill>
           <a:uFillTx/>
           <a:latin typeface="+mj-lt"/>
@@ -1976,9 +2184,9 @@
         <a:buFontTx/>
         <a:buNone/>
         <a:tabLst/>
-        <a:defRPr b="1" baseline="0" cap="none" i="0" spc="0" strike="noStrike" sz="6000" u="none">
+        <a:defRPr b="1" baseline="0" cap="none" i="0" spc="0" strike="noStrike" sz="5400" u="none">
           <a:solidFill>
-            <a:srgbClr val="FFFFFF"/>
+            <a:srgbClr val="FFF2CC"/>
           </a:solidFill>
           <a:uFillTx/>
           <a:latin typeface="+mj-lt"/>
@@ -2002,9 +2210,9 @@
         <a:buFontTx/>
         <a:buNone/>
         <a:tabLst/>
-        <a:defRPr b="1" baseline="0" cap="none" i="0" spc="0" strike="noStrike" sz="6000" u="none">
+        <a:defRPr b="1" baseline="0" cap="none" i="0" spc="0" strike="noStrike" sz="5400" u="none">
           <a:solidFill>
-            <a:srgbClr val="FFFFFF"/>
+            <a:srgbClr val="FFF2CC"/>
           </a:solidFill>
           <a:uFillTx/>
           <a:latin typeface="+mj-lt"/>
@@ -2028,245 +2236,9 @@
         <a:buFontTx/>
         <a:buNone/>
         <a:tabLst/>
-        <a:defRPr b="1" baseline="0" cap="none" i="0" spc="0" strike="noStrike" sz="6000" u="none">
+        <a:defRPr b="1" baseline="0" cap="none" i="0" spc="0" strike="noStrike" sz="5400" u="none">
           <a:solidFill>
-            <a:srgbClr val="FFFFFF"/>
-          </a:solidFill>
-          <a:uFillTx/>
-          <a:latin typeface="+mj-lt"/>
-          <a:ea typeface="+mj-ea"/>
-          <a:cs typeface="+mj-cs"/>
-          <a:sym typeface="Arial"/>
-        </a:defRPr>
-      </a:lvl9pPr>
-    </p:titleStyle>
-    <p:bodyStyle>
-      <a:lvl1pPr marL="0" marR="0" indent="0" algn="l" defTabSz="914400" rtl="0" latinLnBrk="0">
-        <a:lnSpc>
-          <a:spcPct val="100000"/>
-        </a:lnSpc>
-        <a:spcBef>
-          <a:spcPts val="0"/>
-        </a:spcBef>
-        <a:spcAft>
-          <a:spcPts val="0"/>
-        </a:spcAft>
-        <a:buClrTx/>
-        <a:buSzTx/>
-        <a:buFontTx/>
-        <a:buNone/>
-        <a:tabLst/>
-        <a:defRPr b="0" baseline="0" cap="none" i="0" spc="0" strike="noStrike" sz="1400" u="none">
-          <a:solidFill>
-            <a:srgbClr val="000000"/>
-          </a:solidFill>
-          <a:uFillTx/>
-          <a:latin typeface="+mj-lt"/>
-          <a:ea typeface="+mj-ea"/>
-          <a:cs typeface="+mj-cs"/>
-          <a:sym typeface="Arial"/>
-        </a:defRPr>
-      </a:lvl1pPr>
-      <a:lvl2pPr marL="0" marR="0" indent="0" algn="l" defTabSz="914400" rtl="0" latinLnBrk="0">
-        <a:lnSpc>
-          <a:spcPct val="100000"/>
-        </a:lnSpc>
-        <a:spcBef>
-          <a:spcPts val="0"/>
-        </a:spcBef>
-        <a:spcAft>
-          <a:spcPts val="0"/>
-        </a:spcAft>
-        <a:buClrTx/>
-        <a:buSzTx/>
-        <a:buFontTx/>
-        <a:buNone/>
-        <a:tabLst/>
-        <a:defRPr b="0" baseline="0" cap="none" i="0" spc="0" strike="noStrike" sz="1400" u="none">
-          <a:solidFill>
-            <a:srgbClr val="000000"/>
-          </a:solidFill>
-          <a:uFillTx/>
-          <a:latin typeface="+mj-lt"/>
-          <a:ea typeface="+mj-ea"/>
-          <a:cs typeface="+mj-cs"/>
-          <a:sym typeface="Arial"/>
-        </a:defRPr>
-      </a:lvl2pPr>
-      <a:lvl3pPr marL="0" marR="0" indent="0" algn="l" defTabSz="914400" rtl="0" latinLnBrk="0">
-        <a:lnSpc>
-          <a:spcPct val="100000"/>
-        </a:lnSpc>
-        <a:spcBef>
-          <a:spcPts val="0"/>
-        </a:spcBef>
-        <a:spcAft>
-          <a:spcPts val="0"/>
-        </a:spcAft>
-        <a:buClrTx/>
-        <a:buSzTx/>
-        <a:buFontTx/>
-        <a:buNone/>
-        <a:tabLst/>
-        <a:defRPr b="0" baseline="0" cap="none" i="0" spc="0" strike="noStrike" sz="1400" u="none">
-          <a:solidFill>
-            <a:srgbClr val="000000"/>
-          </a:solidFill>
-          <a:uFillTx/>
-          <a:latin typeface="+mj-lt"/>
-          <a:ea typeface="+mj-ea"/>
-          <a:cs typeface="+mj-cs"/>
-          <a:sym typeface="Arial"/>
-        </a:defRPr>
-      </a:lvl3pPr>
-      <a:lvl4pPr marL="0" marR="0" indent="0" algn="l" defTabSz="914400" rtl="0" latinLnBrk="0">
-        <a:lnSpc>
-          <a:spcPct val="100000"/>
-        </a:lnSpc>
-        <a:spcBef>
-          <a:spcPts val="0"/>
-        </a:spcBef>
-        <a:spcAft>
-          <a:spcPts val="0"/>
-        </a:spcAft>
-        <a:buClrTx/>
-        <a:buSzTx/>
-        <a:buFontTx/>
-        <a:buNone/>
-        <a:tabLst/>
-        <a:defRPr b="0" baseline="0" cap="none" i="0" spc="0" strike="noStrike" sz="1400" u="none">
-          <a:solidFill>
-            <a:srgbClr val="000000"/>
-          </a:solidFill>
-          <a:uFillTx/>
-          <a:latin typeface="+mj-lt"/>
-          <a:ea typeface="+mj-ea"/>
-          <a:cs typeface="+mj-cs"/>
-          <a:sym typeface="Arial"/>
-        </a:defRPr>
-      </a:lvl4pPr>
-      <a:lvl5pPr marL="0" marR="0" indent="0" algn="l" defTabSz="914400" rtl="0" latinLnBrk="0">
-        <a:lnSpc>
-          <a:spcPct val="100000"/>
-        </a:lnSpc>
-        <a:spcBef>
-          <a:spcPts val="0"/>
-        </a:spcBef>
-        <a:spcAft>
-          <a:spcPts val="0"/>
-        </a:spcAft>
-        <a:buClrTx/>
-        <a:buSzTx/>
-        <a:buFontTx/>
-        <a:buNone/>
-        <a:tabLst/>
-        <a:defRPr b="0" baseline="0" cap="none" i="0" spc="0" strike="noStrike" sz="1400" u="none">
-          <a:solidFill>
-            <a:srgbClr val="000000"/>
-          </a:solidFill>
-          <a:uFillTx/>
-          <a:latin typeface="+mj-lt"/>
-          <a:ea typeface="+mj-ea"/>
-          <a:cs typeface="+mj-cs"/>
-          <a:sym typeface="Arial"/>
-        </a:defRPr>
-      </a:lvl5pPr>
-      <a:lvl6pPr marL="0" marR="0" indent="0" algn="l" defTabSz="914400" rtl="0" latinLnBrk="0">
-        <a:lnSpc>
-          <a:spcPct val="100000"/>
-        </a:lnSpc>
-        <a:spcBef>
-          <a:spcPts val="0"/>
-        </a:spcBef>
-        <a:spcAft>
-          <a:spcPts val="0"/>
-        </a:spcAft>
-        <a:buClrTx/>
-        <a:buSzTx/>
-        <a:buFontTx/>
-        <a:buNone/>
-        <a:tabLst/>
-        <a:defRPr b="0" baseline="0" cap="none" i="0" spc="0" strike="noStrike" sz="1400" u="none">
-          <a:solidFill>
-            <a:srgbClr val="000000"/>
-          </a:solidFill>
-          <a:uFillTx/>
-          <a:latin typeface="+mj-lt"/>
-          <a:ea typeface="+mj-ea"/>
-          <a:cs typeface="+mj-cs"/>
-          <a:sym typeface="Arial"/>
-        </a:defRPr>
-      </a:lvl6pPr>
-      <a:lvl7pPr marL="0" marR="0" indent="0" algn="l" defTabSz="914400" rtl="0" latinLnBrk="0">
-        <a:lnSpc>
-          <a:spcPct val="100000"/>
-        </a:lnSpc>
-        <a:spcBef>
-          <a:spcPts val="0"/>
-        </a:spcBef>
-        <a:spcAft>
-          <a:spcPts val="0"/>
-        </a:spcAft>
-        <a:buClrTx/>
-        <a:buSzTx/>
-        <a:buFontTx/>
-        <a:buNone/>
-        <a:tabLst/>
-        <a:defRPr b="0" baseline="0" cap="none" i="0" spc="0" strike="noStrike" sz="1400" u="none">
-          <a:solidFill>
-            <a:srgbClr val="000000"/>
-          </a:solidFill>
-          <a:uFillTx/>
-          <a:latin typeface="+mj-lt"/>
-          <a:ea typeface="+mj-ea"/>
-          <a:cs typeface="+mj-cs"/>
-          <a:sym typeface="Arial"/>
-        </a:defRPr>
-      </a:lvl7pPr>
-      <a:lvl8pPr marL="0" marR="0" indent="0" algn="l" defTabSz="914400" rtl="0" latinLnBrk="0">
-        <a:lnSpc>
-          <a:spcPct val="100000"/>
-        </a:lnSpc>
-        <a:spcBef>
-          <a:spcPts val="0"/>
-        </a:spcBef>
-        <a:spcAft>
-          <a:spcPts val="0"/>
-        </a:spcAft>
-        <a:buClrTx/>
-        <a:buSzTx/>
-        <a:buFontTx/>
-        <a:buNone/>
-        <a:tabLst/>
-        <a:defRPr b="0" baseline="0" cap="none" i="0" spc="0" strike="noStrike" sz="1400" u="none">
-          <a:solidFill>
-            <a:srgbClr val="000000"/>
-          </a:solidFill>
-          <a:uFillTx/>
-          <a:latin typeface="+mj-lt"/>
-          <a:ea typeface="+mj-ea"/>
-          <a:cs typeface="+mj-cs"/>
-          <a:sym typeface="Arial"/>
-        </a:defRPr>
-      </a:lvl8pPr>
-      <a:lvl9pPr marL="0" marR="0" indent="0" algn="l" defTabSz="914400" rtl="0" latinLnBrk="0">
-        <a:lnSpc>
-          <a:spcPct val="100000"/>
-        </a:lnSpc>
-        <a:spcBef>
-          <a:spcPts val="0"/>
-        </a:spcBef>
-        <a:spcAft>
-          <a:spcPts val="0"/>
-        </a:spcAft>
-        <a:buClrTx/>
-        <a:buSzTx/>
-        <a:buFontTx/>
-        <a:buNone/>
-        <a:tabLst/>
-        <a:defRPr b="0" baseline="0" cap="none" i="0" spc="0" strike="noStrike" sz="1400" u="none">
-          <a:solidFill>
-            <a:srgbClr val="000000"/>
+            <a:srgbClr val="FFF2CC"/>
           </a:solidFill>
           <a:uFillTx/>
           <a:latin typeface="+mj-lt"/>
@@ -2544,7 +2516,7 @@
         <p:spPr>
           <a:xfrm>
             <a:off x="191344" y="1124744"/>
-            <a:ext cx="1091664" cy="1910969"/>
+            <a:ext cx="1091664" cy="1910970"/>
           </a:xfrm>
           <a:prstGeom prst="rect">
             <a:avLst/>
@@ -2553,12 +2525,19 @@
         <p:txBody>
           <a:bodyPr/>
           <a:lstStyle>
-            <a:lvl1pPr marL="0"/>
+            <a:lvl1pPr indent="0">
+              <a:defRPr b="0">
+                <a:latin typeface="冬青黑体简体中文 W6"/>
+                <a:ea typeface="冬青黑体简体中文 W6"/>
+                <a:cs typeface="冬青黑体简体中文 W6"/>
+                <a:sym typeface="冬青黑体简体中文 W6"/>
+              </a:defRPr>
+            </a:lvl1pPr>
           </a:lstStyle>
           <a:p>
             <a:pPr/>
             <a:r>
-              <a:t>11</a:t>
+              <a:t>9</a:t>
             </a:r>
           </a:p>
         </p:txBody>
@@ -2573,8 +2552,8 @@
         </p:nvSpPr>
         <p:spPr>
           <a:xfrm>
-            <a:off x="191343" y="-1691"/>
-            <a:ext cx="11593290" cy="937979"/>
+            <a:off x="191342" y="-1691"/>
+            <a:ext cx="11593292" cy="937979"/>
           </a:xfrm>
           <a:prstGeom prst="rect">
             <a:avLst/>
@@ -2584,13 +2563,18 @@
           <a:bodyPr/>
           <a:lstStyle>
             <a:lvl1pPr defTabSz="813816">
-              <a:defRPr sz="4806"/>
+              <a:defRPr>
+                <a:latin typeface="DFYuan-Bd-HK-BF"/>
+                <a:ea typeface="DFYuan-Bd-HK-BF"/>
+                <a:cs typeface="DFYuan-Bd-HK-BF"/>
+                <a:sym typeface="DFYuan-Bd-HK-BF"/>
+              </a:defRPr>
             </a:lvl1pPr>
           </a:lstStyle>
           <a:p>
             <a:pPr/>
             <a:r>
-              <a:t>撒母耳記下 1:11-14</a:t>
+              <a:t>撒母耳記下 9:8</a:t>
             </a:r>
           </a:p>
         </p:txBody>
@@ -2616,11 +2600,15 @@
         <p:txBody>
           <a:bodyPr/>
           <a:lstStyle>
-            <a:lvl1pPr>
-              <a:defRPr b="1" sz="5400">
+            <a:lvl1pPr indent="0">
+              <a:defRPr>
                 <a:solidFill>
                   <a:srgbClr val="FFFFFF"/>
                 </a:solidFill>
+                <a:latin typeface="DFYuan-Bd-HK-BF"/>
+                <a:ea typeface="DFYuan-Bd-HK-BF"/>
+                <a:cs typeface="DFYuan-Bd-HK-BF"/>
+                <a:sym typeface="DFYuan-Bd-HK-BF"/>
               </a:defRPr>
             </a:lvl1pPr>
           </a:lstStyle>
@@ -2653,11 +2641,15 @@
         <p:txBody>
           <a:bodyPr/>
           <a:lstStyle>
-            <a:lvl1pPr defTabSz="832104">
-              <a:defRPr b="1" sz="3640">
+            <a:lvl1pPr indent="0" defTabSz="832103">
+              <a:defRPr sz="3600">
                 <a:solidFill>
                   <a:srgbClr val="FBE4D4"/>
                 </a:solidFill>
+                <a:latin typeface="DFYuan-Bd-HK-BF"/>
+                <a:ea typeface="DFYuan-Bd-HK-BF"/>
+                <a:cs typeface="DFYuan-Bd-HK-BF"/>
+                <a:sym typeface="DFYuan-Bd-HK-BF"/>
               </a:defRPr>
             </a:lvl1pPr>
           </a:lstStyle>
@@ -2810,13 +2802,7 @@
           <a:effectLst/>
         </a:effectStyle>
         <a:effectStyle>
-          <a:effectLst>
-            <a:outerShdw sx="100000" sy="100000" kx="0" ky="0" algn="b" rotWithShape="0" blurRad="38100" dist="20000" dir="5400000">
-              <a:srgbClr val="000000">
-                <a:alpha val="38000"/>
-              </a:srgbClr>
-            </a:outerShdw>
-          </a:effectLst>
+          <a:effectLst/>
         </a:effectStyle>
       </a:effectStyleLst>
       <a:bgFillStyleLst>
@@ -2875,7 +2861,7 @@
     <a:spDef>
       <a:spPr>
         <a:solidFill>
-          <a:srgbClr val="FFFFFF"/>
+          <a:srgbClr val="00FF00"/>
         </a:solidFill>
         <a:ln w="25400" cap="flat">
           <a:solidFill>
@@ -2915,10 +2901,10 @@
             </a:solidFill>
             <a:effectLst/>
             <a:uFillTx/>
-            <a:latin typeface="+mj-lt"/>
-            <a:ea typeface="+mj-ea"/>
-            <a:cs typeface="+mj-cs"/>
-            <a:sym typeface="Arial"/>
+            <a:latin typeface="+mn-lt"/>
+            <a:ea typeface="+mn-ea"/>
+            <a:cs typeface="+mn-cs"/>
+            <a:sym typeface="Helvetica"/>
           </a:defRPr>
         </a:defPPr>
         <a:lvl1pPr marL="0" marR="0" indent="0" algn="l" defTabSz="914400" rtl="0" fontAlgn="auto" latinLnBrk="1" hangingPunct="0">
@@ -3173,13 +3159,7 @@
           <a:prstDash val="solid"/>
           <a:round/>
         </a:ln>
-        <a:effectLst>
-          <a:outerShdw sx="100000" sy="100000" kx="0" ky="0" algn="b" rotWithShape="0" blurRad="38100" dist="20000" dir="5400000">
-            <a:srgbClr val="000000">
-              <a:alpha val="38000"/>
-            </a:srgbClr>
-          </a:outerShdw>
-        </a:effectLst>
+        <a:effectLst/>
         <a:sp3d/>
       </a:spPr>
       <a:bodyPr rot="0" spcFirstLastPara="1" vertOverflow="overflow" horzOverflow="overflow" vert="horz" wrap="square" lIns="91439" tIns="45719" rIns="91439" bIns="45719" numCol="1" spcCol="38100" rtlCol="0" anchor="t" upright="0">
@@ -3492,10 +3472,10 @@
             </a:solidFill>
             <a:effectLst/>
             <a:uFillTx/>
-            <a:latin typeface="+mj-lt"/>
-            <a:ea typeface="+mj-ea"/>
-            <a:cs typeface="+mj-cs"/>
-            <a:sym typeface="Arial"/>
+            <a:latin typeface="+mn-lt"/>
+            <a:ea typeface="+mn-ea"/>
+            <a:cs typeface="+mn-cs"/>
+            <a:sym typeface="Helvetica"/>
           </a:defRPr>
         </a:defPPr>
         <a:lvl1pPr marL="0" marR="0" indent="0" algn="l" defTabSz="914400" rtl="0" fontAlgn="auto" latinLnBrk="1" hangingPunct="0">
@@ -3876,13 +3856,7 @@
           <a:effectLst/>
         </a:effectStyle>
         <a:effectStyle>
-          <a:effectLst>
-            <a:outerShdw sx="100000" sy="100000" kx="0" ky="0" algn="b" rotWithShape="0" blurRad="38100" dist="20000" dir="5400000">
-              <a:srgbClr val="000000">
-                <a:alpha val="38000"/>
-              </a:srgbClr>
-            </a:outerShdw>
-          </a:effectLst>
+          <a:effectLst/>
         </a:effectStyle>
       </a:effectStyleLst>
       <a:bgFillStyleLst>
@@ -3941,7 +3915,7 @@
     <a:spDef>
       <a:spPr>
         <a:solidFill>
-          <a:srgbClr val="FFFFFF"/>
+          <a:srgbClr val="00FF00"/>
         </a:solidFill>
         <a:ln w="25400" cap="flat">
           <a:solidFill>
@@ -3981,10 +3955,10 @@
             </a:solidFill>
             <a:effectLst/>
             <a:uFillTx/>
-            <a:latin typeface="+mj-lt"/>
-            <a:ea typeface="+mj-ea"/>
-            <a:cs typeface="+mj-cs"/>
-            <a:sym typeface="Arial"/>
+            <a:latin typeface="+mn-lt"/>
+            <a:ea typeface="+mn-ea"/>
+            <a:cs typeface="+mn-cs"/>
+            <a:sym typeface="Helvetica"/>
           </a:defRPr>
         </a:defPPr>
         <a:lvl1pPr marL="0" marR="0" indent="0" algn="l" defTabSz="914400" rtl="0" fontAlgn="auto" latinLnBrk="1" hangingPunct="0">
@@ -4239,13 +4213,7 @@
           <a:prstDash val="solid"/>
           <a:round/>
         </a:ln>
-        <a:effectLst>
-          <a:outerShdw sx="100000" sy="100000" kx="0" ky="0" algn="b" rotWithShape="0" blurRad="38100" dist="20000" dir="5400000">
-            <a:srgbClr val="000000">
-              <a:alpha val="38000"/>
-            </a:srgbClr>
-          </a:outerShdw>
-        </a:effectLst>
+        <a:effectLst/>
         <a:sp3d/>
       </a:spPr>
       <a:bodyPr rot="0" spcFirstLastPara="1" vertOverflow="overflow" horzOverflow="overflow" vert="horz" wrap="square" lIns="91439" tIns="45719" rIns="91439" bIns="45719" numCol="1" spcCol="38100" rtlCol="0" anchor="t" upright="0">
@@ -4558,10 +4526,10 @@
             </a:solidFill>
             <a:effectLst/>
             <a:uFillTx/>
-            <a:latin typeface="+mj-lt"/>
-            <a:ea typeface="+mj-ea"/>
-            <a:cs typeface="+mj-cs"/>
-            <a:sym typeface="Arial"/>
+            <a:latin typeface="+mn-lt"/>
+            <a:ea typeface="+mn-ea"/>
+            <a:cs typeface="+mn-cs"/>
+            <a:sym typeface="Helvetica"/>
           </a:defRPr>
         </a:defPPr>
         <a:lvl1pPr marL="0" marR="0" indent="0" algn="l" defTabSz="914400" rtl="0" fontAlgn="auto" latinLnBrk="1" hangingPunct="0">

</xml_diff>

<commit_message>
style(template): 更新經文範本 PPT 模板
</commit_message>
<xml_diff>
--- a/經文範本.pptx
+++ b/經文範本.pptx
@@ -1,14 +1,14 @@
 
 <file path=ppt/presentation.xml><?xml version="1.0" encoding="utf-8"?>
-<p:presentation xmlns:a="http://schemas.openxmlformats.org/drawingml/2006/main" xmlns:r="http://schemas.openxmlformats.org/officeDocument/2006/relationships" xmlns:p="http://schemas.openxmlformats.org/presentationml/2006/main" xmlns:m="http://schemas.openxmlformats.org/officeDocument/2006/math" xmlns:a14="http://schemas.microsoft.com/office/drawing/2010/main">
+<p:presentation xmlns:a="http://schemas.openxmlformats.org/drawingml/2006/main" xmlns:r="http://schemas.openxmlformats.org/officeDocument/2006/relationships" xmlns:p="http://schemas.openxmlformats.org/presentationml/2006/main">
   <p:sldMasterIdLst>
-    <p:sldMasterId id="2147483648" r:id="rId5"/>
+    <p:sldMasterId id="2147483648" r:id="rId1"/>
   </p:sldMasterIdLst>
   <p:notesMasterIdLst>
-    <p:notesMasterId r:id="rId7"/>
+    <p:notesMasterId r:id="rId3"/>
   </p:notesMasterIdLst>
   <p:sldIdLst>
-    <p:sldId id="256" r:id="rId8"/>
+    <p:sldId id="256" r:id="rId2"/>
   </p:sldIdLst>
   <p:sldSz cx="12192000" cy="6858000"/>
   <p:notesSz cx="6858000" cy="9144000"/>
@@ -28,7 +28,7 @@
       <a:buFontTx/>
       <a:buNone/>
       <a:tabLst/>
-      <a:defRPr b="0" baseline="0" cap="none" i="0" spc="0" strike="noStrike" sz="1800" u="none" kumimoji="0" normalizeH="0">
+      <a:defRPr kumimoji="0" sz="1800" b="0" i="0" u="none" strike="noStrike" cap="none" spc="0" normalizeH="0" baseline="0">
         <a:ln>
           <a:noFill/>
         </a:ln>
@@ -54,7 +54,7 @@
       <a:buFontTx/>
       <a:buNone/>
       <a:tabLst/>
-      <a:defRPr b="0" baseline="0" cap="none" i="0" spc="0" strike="noStrike" sz="1400" u="none" kumimoji="0" normalizeH="0">
+      <a:defRPr kumimoji="0" sz="1400" b="0" i="0" u="none" strike="noStrike" cap="none" spc="0" normalizeH="0" baseline="0">
         <a:ln>
           <a:noFill/>
         </a:ln>
@@ -84,7 +84,7 @@
       <a:buFontTx/>
       <a:buNone/>
       <a:tabLst/>
-      <a:defRPr b="0" baseline="0" cap="none" i="0" spc="0" strike="noStrike" sz="1400" u="none" kumimoji="0" normalizeH="0">
+      <a:defRPr kumimoji="0" sz="1400" b="0" i="0" u="none" strike="noStrike" cap="none" spc="0" normalizeH="0" baseline="0">
         <a:ln>
           <a:noFill/>
         </a:ln>
@@ -114,7 +114,7 @@
       <a:buFontTx/>
       <a:buNone/>
       <a:tabLst/>
-      <a:defRPr b="0" baseline="0" cap="none" i="0" spc="0" strike="noStrike" sz="1400" u="none" kumimoji="0" normalizeH="0">
+      <a:defRPr kumimoji="0" sz="1400" b="0" i="0" u="none" strike="noStrike" cap="none" spc="0" normalizeH="0" baseline="0">
         <a:ln>
           <a:noFill/>
         </a:ln>
@@ -144,7 +144,7 @@
       <a:buFontTx/>
       <a:buNone/>
       <a:tabLst/>
-      <a:defRPr b="0" baseline="0" cap="none" i="0" spc="0" strike="noStrike" sz="1400" u="none" kumimoji="0" normalizeH="0">
+      <a:defRPr kumimoji="0" sz="1400" b="0" i="0" u="none" strike="noStrike" cap="none" spc="0" normalizeH="0" baseline="0">
         <a:ln>
           <a:noFill/>
         </a:ln>
@@ -174,7 +174,7 @@
       <a:buFontTx/>
       <a:buNone/>
       <a:tabLst/>
-      <a:defRPr b="0" baseline="0" cap="none" i="0" spc="0" strike="noStrike" sz="1400" u="none" kumimoji="0" normalizeH="0">
+      <a:defRPr kumimoji="0" sz="1400" b="0" i="0" u="none" strike="noStrike" cap="none" spc="0" normalizeH="0" baseline="0">
         <a:ln>
           <a:noFill/>
         </a:ln>
@@ -204,7 +204,7 @@
       <a:buFontTx/>
       <a:buNone/>
       <a:tabLst/>
-      <a:defRPr b="0" baseline="0" cap="none" i="0" spc="0" strike="noStrike" sz="1400" u="none" kumimoji="0" normalizeH="0">
+      <a:defRPr kumimoji="0" sz="1400" b="0" i="0" u="none" strike="noStrike" cap="none" spc="0" normalizeH="0" baseline="0">
         <a:ln>
           <a:noFill/>
         </a:ln>
@@ -234,7 +234,7 @@
       <a:buFontTx/>
       <a:buNone/>
       <a:tabLst/>
-      <a:defRPr b="0" baseline="0" cap="none" i="0" spc="0" strike="noStrike" sz="1400" u="none" kumimoji="0" normalizeH="0">
+      <a:defRPr kumimoji="0" sz="1400" b="0" i="0" u="none" strike="noStrike" cap="none" spc="0" normalizeH="0" baseline="0">
         <a:ln>
           <a:noFill/>
         </a:ln>
@@ -264,7 +264,7 @@
       <a:buFontTx/>
       <a:buNone/>
       <a:tabLst/>
-      <a:defRPr b="0" baseline="0" cap="none" i="0" spc="0" strike="noStrike" sz="1400" u="none" kumimoji="0" normalizeH="0">
+      <a:defRPr kumimoji="0" sz="1400" b="0" i="0" u="none" strike="noStrike" cap="none" spc="0" normalizeH="0" baseline="0">
         <a:ln>
           <a:noFill/>
         </a:ln>
@@ -294,7 +294,7 @@
       <a:buFontTx/>
       <a:buNone/>
       <a:tabLst/>
-      <a:defRPr b="0" baseline="0" cap="none" i="0" spc="0" strike="noStrike" sz="1400" u="none" kumimoji="0" normalizeH="0">
+      <a:defRPr kumimoji="0" sz="1400" b="0" i="0" u="none" strike="noStrike" cap="none" spc="0" normalizeH="0" baseline="0">
         <a:ln>
           <a:noFill/>
         </a:ln>
@@ -313,13 +313,14 @@
 </p:presentation>
 </file>
 
-<file path=ppt/commentAuthors.xml><?xml version="1.0" encoding="utf-8"?>
-<p:cmAuthorLst xmlns:a="http://schemas.openxmlformats.org/drawingml/2006/main" xmlns:r="http://schemas.openxmlformats.org/officeDocument/2006/relationships" xmlns:p="http://schemas.openxmlformats.org/presentationml/2006/main" xmlns:m="http://schemas.openxmlformats.org/officeDocument/2006/math" xmlns:a14="http://schemas.microsoft.com/office/drawing/2010/main"/>
-</file>
-
 <file path=ppt/notesMasters/notesMaster1.xml><?xml version="1.0" encoding="utf-8"?>
-<p:notesMaster xmlns:a="http://schemas.openxmlformats.org/drawingml/2006/main" xmlns:r="http://schemas.openxmlformats.org/officeDocument/2006/relationships" xmlns:p="http://schemas.openxmlformats.org/presentationml/2006/main" xmlns:m="http://schemas.openxmlformats.org/officeDocument/2006/math" xmlns:a14="http://schemas.microsoft.com/office/drawing/2010/main">
+<p:notesMaster xmlns:a="http://schemas.openxmlformats.org/drawingml/2006/main" xmlns:r="http://schemas.openxmlformats.org/officeDocument/2006/relationships" xmlns:p="http://schemas.openxmlformats.org/presentationml/2006/main">
   <p:cSld>
+    <p:bg>
+      <p:bgRef idx="1001">
+        <a:schemeClr val="bg1"/>
+      </p:bgRef>
+    </p:bg>
     <p:spTree>
       <p:nvGrpSpPr>
         <p:cNvPr id="1" name=""/>
@@ -337,7 +338,9 @@
       <p:sp>
         <p:nvSpPr>
           <p:cNvPr id="67" name="Shape 67"/>
-          <p:cNvSpPr/>
+          <p:cNvSpPr>
+            <a:spLocks noGrp="1" noRot="1" noChangeAspect="1"/>
+          </p:cNvSpPr>
           <p:nvPr>
             <p:ph type="sldImg"/>
           </p:nvPr>
@@ -355,14 +358,16 @@
           <a:bodyPr/>
           <a:lstStyle/>
           <a:p>
-            <a:pPr/>
+            <a:endParaRPr/>
           </a:p>
         </p:txBody>
       </p:sp>
       <p:sp>
         <p:nvSpPr>
           <p:cNvPr id="68" name="Shape 68"/>
-          <p:cNvSpPr/>
+          <p:cNvSpPr>
+            <a:spLocks noGrp="1"/>
+          </p:cNvSpPr>
           <p:nvPr>
             <p:ph type="body" sz="quarter" idx="1"/>
           </p:nvPr>
@@ -380,7 +385,7 @@
           <a:bodyPr/>
           <a:lstStyle/>
           <a:p>
-            <a:pPr/>
+            <a:endParaRPr/>
           </a:p>
         </p:txBody>
       </p:sp>
@@ -465,13 +470,14 @@
 </file>
 
 <file path=ppt/slideLayouts/slideLayout1.xml><?xml version="1.0" encoding="utf-8"?>
-<p:sldLayout xmlns:a="http://schemas.openxmlformats.org/drawingml/2006/main" xmlns:r="http://schemas.openxmlformats.org/officeDocument/2006/relationships" xmlns:p="http://schemas.openxmlformats.org/presentationml/2006/main" xmlns:m="http://schemas.openxmlformats.org/officeDocument/2006/math" xmlns:a14="http://schemas.microsoft.com/office/drawing/2010/main" type="tx" showMasterSp="1" showMasterPhAnim="1">
+<p:sldLayout xmlns:a="http://schemas.openxmlformats.org/drawingml/2006/main" xmlns:r="http://schemas.openxmlformats.org/officeDocument/2006/relationships" xmlns:p="http://schemas.openxmlformats.org/presentationml/2006/main" type="tx">
   <p:cSld name="標題及文字">
     <p:bg>
       <p:bgPr>
         <a:solidFill>
           <a:srgbClr val="00FF00"/>
         </a:solidFill>
+        <a:effectLst/>
       </p:bgPr>
     </p:bg>
     <p:spTree>
@@ -491,7 +497,9 @@
       <p:sp>
         <p:nvSpPr>
           <p:cNvPr id="11" name="大標題文字"/>
-          <p:cNvSpPr txBox="1"/>
+          <p:cNvSpPr txBox="1">
+            <a:spLocks noGrp="1"/>
+          </p:cNvSpPr>
           <p:nvPr>
             <p:ph type="title"/>
           </p:nvPr>
@@ -517,7 +525,6 @@
             </a:lvl1pPr>
           </a:lstStyle>
           <a:p>
-            <a:pPr/>
             <a:r>
               <a:t>大標題文字</a:t>
             </a:r>
@@ -527,7 +534,9 @@
       <p:sp>
         <p:nvSpPr>
           <p:cNvPr id="12" name="內文層級一…"/>
-          <p:cNvSpPr txBox="1"/>
+          <p:cNvSpPr txBox="1">
+            <a:spLocks noGrp="1"/>
+          </p:cNvSpPr>
           <p:nvPr>
             <p:ph type="body" sz="quarter" idx="1"/>
           </p:nvPr>
@@ -543,7 +552,7 @@
         </p:spPr>
         <p:txBody>
           <a:bodyPr lIns="45699" tIns="45699" rIns="45699" bIns="45699">
-            <a:normAutofit fontScale="100000" lnSpcReduction="0"/>
+            <a:normAutofit/>
           </a:bodyPr>
           <a:lstStyle>
             <a:lvl1pPr marL="228600" algn="ctr">
@@ -553,7 +562,7 @@
               <a:spcBef>
                 <a:spcPts val="1000"/>
               </a:spcBef>
-              <a:defRPr b="1" sz="100">
+              <a:defRPr sz="100" b="1">
                 <a:solidFill>
                   <a:srgbClr val="FFE389"/>
                 </a:solidFill>
@@ -568,7 +577,7 @@
               </a:spcBef>
               <a:buSzPts val="100"/>
               <a:buChar char="•"/>
-              <a:defRPr b="1" sz="100">
+              <a:defRPr sz="100" b="1">
                 <a:solidFill>
                   <a:srgbClr val="FFE389"/>
                 </a:solidFill>
@@ -583,7 +592,7 @@
               </a:spcBef>
               <a:buSzPts val="100"/>
               <a:buChar char="•"/>
-              <a:defRPr b="1" sz="100">
+              <a:defRPr sz="100" b="1">
                 <a:solidFill>
                   <a:srgbClr val="FFE389"/>
                 </a:solidFill>
@@ -598,7 +607,7 @@
               </a:spcBef>
               <a:buSzPts val="100"/>
               <a:buChar char="•"/>
-              <a:defRPr b="1" sz="100">
+              <a:defRPr sz="100" b="1">
                 <a:solidFill>
                   <a:srgbClr val="FFE389"/>
                 </a:solidFill>
@@ -613,7 +622,7 @@
               </a:spcBef>
               <a:buSzPts val="100"/>
               <a:buChar char="•"/>
-              <a:defRPr b="1" sz="100">
+              <a:defRPr sz="100" b="1">
                 <a:solidFill>
                   <a:srgbClr val="FFE389"/>
                 </a:solidFill>
@@ -621,7 +630,6 @@
             </a:lvl5pPr>
           </a:lstStyle>
           <a:p>
-            <a:pPr/>
             <a:r>
               <a:t>內文層級一</a:t>
             </a:r>
@@ -655,7 +663,9 @@
       <p:sp>
         <p:nvSpPr>
           <p:cNvPr id="13" name="幻燈片編號"/>
-          <p:cNvSpPr txBox="1"/>
+          <p:cNvSpPr txBox="1">
+            <a:spLocks noGrp="1"/>
+          </p:cNvSpPr>
           <p:nvPr>
             <p:ph type="sldNum" sz="quarter" idx="2"/>
           </p:nvPr>
@@ -669,8 +679,10 @@
           <a:bodyPr/>
           <a:lstStyle/>
           <a:p>
-            <a:pPr/>
-            <a:fld id="{86CB4B4D-7CA3-9044-876B-883B54F8677D}" type="slidenum"/>
+            <a:fld id="{86CB4B4D-7CA3-9044-876B-883B54F8677D}" type="slidenum">
+              <a:t>‹#›</a:t>
+            </a:fld>
+            <a:endParaRPr/>
           </a:p>
         </p:txBody>
       </p:sp>
@@ -679,18 +691,19 @@
   <p:clrMapOvr>
     <a:masterClrMapping/>
   </p:clrMapOvr>
-  <p:transition xmlns:p14="http://schemas.microsoft.com/office/powerpoint/2010/main" spd="med" advClick="1"/>
+  <p:transition spd="med"/>
 </p:sldLayout>
 </file>
 
 <file path=ppt/slideLayouts/slideLayout2.xml><?xml version="1.0" encoding="utf-8"?>
-<p:sldLayout xmlns:a="http://schemas.openxmlformats.org/drawingml/2006/main" xmlns:r="http://schemas.openxmlformats.org/officeDocument/2006/relationships" xmlns:p="http://schemas.openxmlformats.org/presentationml/2006/main" xmlns:m="http://schemas.openxmlformats.org/officeDocument/2006/math" xmlns:a14="http://schemas.microsoft.com/office/drawing/2010/main" type="tx" showMasterSp="1" showMasterPhAnim="1">
+<p:sldLayout xmlns:a="http://schemas.openxmlformats.org/drawingml/2006/main" xmlns:r="http://schemas.openxmlformats.org/officeDocument/2006/relationships" xmlns:p="http://schemas.openxmlformats.org/presentationml/2006/main" type="tx">
   <p:cSld name="標題投影片">
     <p:bg>
       <p:bgPr>
         <a:solidFill>
           <a:srgbClr val="00FF00"/>
         </a:solidFill>
+        <a:effectLst/>
       </p:bgPr>
     </p:bg>
     <p:spTree>
@@ -710,7 +723,9 @@
       <p:sp>
         <p:nvSpPr>
           <p:cNvPr id="20" name="內文層級一…"/>
-          <p:cNvSpPr txBox="1"/>
+          <p:cNvSpPr txBox="1">
+            <a:spLocks noGrp="1"/>
+          </p:cNvSpPr>
           <p:nvPr>
             <p:ph type="body" sz="half" idx="1"/>
           </p:nvPr>
@@ -726,39 +741,39 @@
         </p:spPr>
         <p:txBody>
           <a:bodyPr lIns="45699" tIns="45699" rIns="45699" bIns="45699">
-            <a:normAutofit fontScale="100000" lnSpcReduction="0"/>
+            <a:normAutofit/>
           </a:bodyPr>
           <a:lstStyle>
             <a:lvl1pPr algn="ctr">
-              <a:defRPr b="1" sz="4800">
+              <a:defRPr sz="4800" b="1">
                 <a:solidFill>
                   <a:srgbClr val="FFFFFF"/>
                 </a:solidFill>
               </a:defRPr>
             </a:lvl1pPr>
             <a:lvl2pPr algn="ctr">
-              <a:defRPr b="1" sz="4800">
+              <a:defRPr sz="4800" b="1">
                 <a:solidFill>
                   <a:srgbClr val="FFFFFF"/>
                 </a:solidFill>
               </a:defRPr>
             </a:lvl2pPr>
             <a:lvl3pPr algn="ctr">
-              <a:defRPr b="1" sz="4800">
+              <a:defRPr sz="4800" b="1">
                 <a:solidFill>
                   <a:srgbClr val="FFFFFF"/>
                 </a:solidFill>
               </a:defRPr>
             </a:lvl3pPr>
             <a:lvl4pPr algn="ctr">
-              <a:defRPr b="1" sz="4800">
+              <a:defRPr sz="4800" b="1">
                 <a:solidFill>
                   <a:srgbClr val="FFFFFF"/>
                 </a:solidFill>
               </a:defRPr>
             </a:lvl4pPr>
             <a:lvl5pPr algn="ctr">
-              <a:defRPr b="1" sz="4800">
+              <a:defRPr sz="4800" b="1">
                 <a:solidFill>
                   <a:srgbClr val="FFFFFF"/>
                 </a:solidFill>
@@ -766,7 +781,6 @@
             </a:lvl5pPr>
           </a:lstStyle>
           <a:p>
-            <a:pPr/>
             <a:r>
               <a:t>內文層級一</a:t>
             </a:r>
@@ -800,7 +814,9 @@
       <p:sp>
         <p:nvSpPr>
           <p:cNvPr id="21" name="大標題文字"/>
-          <p:cNvSpPr txBox="1"/>
+          <p:cNvSpPr txBox="1">
+            <a:spLocks noGrp="1"/>
+          </p:cNvSpPr>
           <p:nvPr>
             <p:ph type="title"/>
           </p:nvPr>
@@ -829,7 +845,6 @@
             </a:lvl1pPr>
           </a:lstStyle>
           <a:p>
-            <a:pPr/>
             <a:r>
               <a:t>大標題文字</a:t>
             </a:r>
@@ -839,7 +854,9 @@
       <p:sp>
         <p:nvSpPr>
           <p:cNvPr id="22" name="Google Shape;17;p3"/>
-          <p:cNvSpPr txBox="1"/>
+          <p:cNvSpPr txBox="1">
+            <a:spLocks noGrp="1"/>
+          </p:cNvSpPr>
           <p:nvPr>
             <p:ph type="body" sz="quarter" idx="21"/>
           </p:nvPr>
@@ -855,24 +872,27 @@
         </p:spPr>
         <p:txBody>
           <a:bodyPr lIns="45699" tIns="45699" rIns="45699" bIns="45699">
-            <a:normAutofit fontScale="100000" lnSpcReduction="0"/>
+            <a:normAutofit/>
           </a:bodyPr>
           <a:lstStyle/>
           <a:p>
             <a:pPr marL="228600" algn="ctr">
-              <a:defRPr b="1" sz="3200">
+              <a:defRPr sz="3200" b="1">
                 <a:solidFill>
                   <a:srgbClr val="FFFF00"/>
                 </a:solidFill>
               </a:defRPr>
             </a:pPr>
+            <a:endParaRPr/>
           </a:p>
         </p:txBody>
       </p:sp>
       <p:sp>
         <p:nvSpPr>
           <p:cNvPr id="23" name="幻燈片編號"/>
-          <p:cNvSpPr txBox="1"/>
+          <p:cNvSpPr txBox="1">
+            <a:spLocks noGrp="1"/>
+          </p:cNvSpPr>
           <p:nvPr>
             <p:ph type="sldNum" sz="quarter" idx="2"/>
           </p:nvPr>
@@ -886,8 +906,10 @@
           <a:bodyPr/>
           <a:lstStyle/>
           <a:p>
-            <a:pPr/>
-            <a:fld id="{86CB4B4D-7CA3-9044-876B-883B54F8677D}" type="slidenum"/>
+            <a:fld id="{86CB4B4D-7CA3-9044-876B-883B54F8677D}" type="slidenum">
+              <a:t>‹#›</a:t>
+            </a:fld>
+            <a:endParaRPr/>
           </a:p>
         </p:txBody>
       </p:sp>
@@ -896,12 +918,12 @@
   <p:clrMapOvr>
     <a:masterClrMapping/>
   </p:clrMapOvr>
-  <p:transition xmlns:p14="http://schemas.microsoft.com/office/powerpoint/2010/main" spd="med" advClick="1"/>
+  <p:transition spd="med"/>
 </p:sldLayout>
 </file>
 
 <file path=ppt/slideLayouts/slideLayout3.xml><?xml version="1.0" encoding="utf-8"?>
-<p:sldLayout xmlns:a="http://schemas.openxmlformats.org/drawingml/2006/main" xmlns:r="http://schemas.openxmlformats.org/officeDocument/2006/relationships" xmlns:p="http://schemas.openxmlformats.org/presentationml/2006/main" xmlns:m="http://schemas.openxmlformats.org/officeDocument/2006/math" xmlns:a14="http://schemas.microsoft.com/office/drawing/2010/main" type="tx" showMasterSp="1" showMasterPhAnim="1">
+<p:sldLayout xmlns:a="http://schemas.openxmlformats.org/drawingml/2006/main" xmlns:r="http://schemas.openxmlformats.org/officeDocument/2006/relationships" xmlns:p="http://schemas.openxmlformats.org/presentationml/2006/main" type="tx">
   <p:cSld name="1_自訂版面配置">
     <p:spTree>
       <p:nvGrpSpPr>
@@ -920,7 +942,9 @@
       <p:sp>
         <p:nvSpPr>
           <p:cNvPr id="30" name="大標題文字"/>
-          <p:cNvSpPr txBox="1"/>
+          <p:cNvSpPr txBox="1">
+            <a:spLocks noGrp="1"/>
+          </p:cNvSpPr>
           <p:nvPr>
             <p:ph type="title"/>
           </p:nvPr>
@@ -934,7 +958,6 @@
           <a:bodyPr/>
           <a:lstStyle/>
           <a:p>
-            <a:pPr/>
             <a:r>
               <a:t>大標題文字</a:t>
             </a:r>
@@ -944,7 +967,9 @@
       <p:sp>
         <p:nvSpPr>
           <p:cNvPr id="31" name="幻燈片編號"/>
-          <p:cNvSpPr txBox="1"/>
+          <p:cNvSpPr txBox="1">
+            <a:spLocks noGrp="1"/>
+          </p:cNvSpPr>
           <p:nvPr>
             <p:ph type="sldNum" sz="quarter" idx="2"/>
           </p:nvPr>
@@ -958,8 +983,10 @@
           <a:bodyPr/>
           <a:lstStyle/>
           <a:p>
-            <a:pPr/>
-            <a:fld id="{86CB4B4D-7CA3-9044-876B-883B54F8677D}" type="slidenum"/>
+            <a:fld id="{86CB4B4D-7CA3-9044-876B-883B54F8677D}" type="slidenum">
+              <a:t>‹#›</a:t>
+            </a:fld>
+            <a:endParaRPr/>
           </a:p>
         </p:txBody>
       </p:sp>
@@ -968,12 +995,12 @@
   <p:clrMapOvr>
     <a:masterClrMapping/>
   </p:clrMapOvr>
-  <p:transition xmlns:p14="http://schemas.microsoft.com/office/powerpoint/2010/main" spd="med" advClick="1"/>
+  <p:transition spd="med"/>
 </p:sldLayout>
 </file>
 
 <file path=ppt/slideLayouts/slideLayout4.xml><?xml version="1.0" encoding="utf-8"?>
-<p:sldLayout xmlns:a="http://schemas.openxmlformats.org/drawingml/2006/main" xmlns:r="http://schemas.openxmlformats.org/officeDocument/2006/relationships" xmlns:p="http://schemas.openxmlformats.org/presentationml/2006/main" xmlns:m="http://schemas.openxmlformats.org/officeDocument/2006/math" xmlns:a14="http://schemas.microsoft.com/office/drawing/2010/main" type="tx" showMasterSp="1" showMasterPhAnim="1">
+<p:sldLayout xmlns:a="http://schemas.openxmlformats.org/drawingml/2006/main" xmlns:r="http://schemas.openxmlformats.org/officeDocument/2006/relationships" xmlns:p="http://schemas.openxmlformats.org/presentationml/2006/main" type="tx">
   <p:cSld name="1_標題投影片">
     <p:spTree>
       <p:nvGrpSpPr>
@@ -992,7 +1019,9 @@
       <p:sp>
         <p:nvSpPr>
           <p:cNvPr id="38" name="內文層級一…"/>
-          <p:cNvSpPr txBox="1"/>
+          <p:cNvSpPr txBox="1">
+            <a:spLocks noGrp="1"/>
+          </p:cNvSpPr>
           <p:nvPr>
             <p:ph type="body" sz="quarter" idx="1"/>
           </p:nvPr>
@@ -1008,39 +1037,39 @@
         </p:spPr>
         <p:txBody>
           <a:bodyPr lIns="45699" tIns="45699" rIns="45699" bIns="45699">
-            <a:normAutofit fontScale="100000" lnSpcReduction="0"/>
+            <a:normAutofit/>
           </a:bodyPr>
           <a:lstStyle>
             <a:lvl1pPr marL="228600" algn="ctr">
-              <a:defRPr b="1" baseline="30000" sz="5400">
+              <a:defRPr sz="5400" b="1" baseline="30000">
                 <a:solidFill>
                   <a:srgbClr val="FFFF00"/>
                 </a:solidFill>
               </a:defRPr>
             </a:lvl1pPr>
             <a:lvl2pPr marL="228600" indent="457200" algn="ctr">
-              <a:defRPr b="1" baseline="30000" sz="5400">
+              <a:defRPr sz="5400" b="1" baseline="30000">
                 <a:solidFill>
                   <a:srgbClr val="FFFF00"/>
                 </a:solidFill>
               </a:defRPr>
             </a:lvl2pPr>
             <a:lvl3pPr marL="228600" indent="914400" algn="ctr">
-              <a:defRPr b="1" baseline="30000" sz="5400">
+              <a:defRPr sz="5400" b="1" baseline="30000">
                 <a:solidFill>
                   <a:srgbClr val="FFFF00"/>
                 </a:solidFill>
               </a:defRPr>
             </a:lvl3pPr>
             <a:lvl4pPr marL="228600" indent="1371600" algn="ctr">
-              <a:defRPr b="1" baseline="30000" sz="5400">
+              <a:defRPr sz="5400" b="1" baseline="30000">
                 <a:solidFill>
                   <a:srgbClr val="FFFF00"/>
                 </a:solidFill>
               </a:defRPr>
             </a:lvl4pPr>
             <a:lvl5pPr marL="228600" indent="1828800" algn="ctr">
-              <a:defRPr b="1" baseline="30000" sz="5400">
+              <a:defRPr sz="5400" b="1" baseline="30000">
                 <a:solidFill>
                   <a:srgbClr val="FFFF00"/>
                 </a:solidFill>
@@ -1048,7 +1077,6 @@
             </a:lvl5pPr>
           </a:lstStyle>
           <a:p>
-            <a:pPr/>
             <a:r>
               <a:t>內文層級一</a:t>
             </a:r>
@@ -1082,7 +1110,9 @@
       <p:sp>
         <p:nvSpPr>
           <p:cNvPr id="39" name="大標題文字"/>
-          <p:cNvSpPr txBox="1"/>
+          <p:cNvSpPr txBox="1">
+            <a:spLocks noGrp="1"/>
+          </p:cNvSpPr>
           <p:nvPr>
             <p:ph type="title"/>
           </p:nvPr>
@@ -1108,7 +1138,6 @@
             </a:lvl1pPr>
           </a:lstStyle>
           <a:p>
-            <a:pPr/>
             <a:r>
               <a:t>大標題文字</a:t>
             </a:r>
@@ -1118,7 +1147,9 @@
       <p:sp>
         <p:nvSpPr>
           <p:cNvPr id="40" name="Google Shape;26;p6"/>
-          <p:cNvSpPr txBox="1"/>
+          <p:cNvSpPr txBox="1">
+            <a:spLocks noGrp="1"/>
+          </p:cNvSpPr>
           <p:nvPr>
             <p:ph type="body" idx="21"/>
           </p:nvPr>
@@ -1134,24 +1165,27 @@
         </p:spPr>
         <p:txBody>
           <a:bodyPr lIns="45699" tIns="45699" rIns="45699" bIns="45699">
-            <a:normAutofit fontScale="100000" lnSpcReduction="0"/>
+            <a:normAutofit/>
           </a:bodyPr>
           <a:lstStyle/>
           <a:p>
             <a:pPr marL="228600">
-              <a:defRPr b="1" sz="5400">
+              <a:defRPr sz="5400" b="1">
                 <a:solidFill>
                   <a:srgbClr val="FFFFFF"/>
                 </a:solidFill>
               </a:defRPr>
             </a:pPr>
+            <a:endParaRPr/>
           </a:p>
         </p:txBody>
       </p:sp>
       <p:sp>
         <p:nvSpPr>
           <p:cNvPr id="41" name="Google Shape;27;p6"/>
-          <p:cNvSpPr txBox="1"/>
+          <p:cNvSpPr txBox="1">
+            <a:spLocks noGrp="1"/>
+          </p:cNvSpPr>
           <p:nvPr>
             <p:ph type="body" sz="quarter" idx="22"/>
           </p:nvPr>
@@ -1167,24 +1201,27 @@
         </p:spPr>
         <p:txBody>
           <a:bodyPr lIns="45699" tIns="45699" rIns="45699" bIns="45699">
-            <a:normAutofit fontScale="100000" lnSpcReduction="0"/>
+            <a:normAutofit/>
           </a:bodyPr>
           <a:lstStyle/>
           <a:p>
             <a:pPr marL="228600">
-              <a:defRPr b="1" sz="4000">
+              <a:defRPr sz="4000" b="1">
                 <a:solidFill>
                   <a:srgbClr val="FBE4D4"/>
                 </a:solidFill>
               </a:defRPr>
             </a:pPr>
+            <a:endParaRPr/>
           </a:p>
         </p:txBody>
       </p:sp>
       <p:sp>
         <p:nvSpPr>
           <p:cNvPr id="42" name="幻燈片編號"/>
-          <p:cNvSpPr txBox="1"/>
+          <p:cNvSpPr txBox="1">
+            <a:spLocks noGrp="1"/>
+          </p:cNvSpPr>
           <p:nvPr>
             <p:ph type="sldNum" sz="quarter" idx="2"/>
           </p:nvPr>
@@ -1198,8 +1235,10 @@
           <a:bodyPr/>
           <a:lstStyle/>
           <a:p>
-            <a:pPr/>
-            <a:fld id="{86CB4B4D-7CA3-9044-876B-883B54F8677D}" type="slidenum"/>
+            <a:fld id="{86CB4B4D-7CA3-9044-876B-883B54F8677D}" type="slidenum">
+              <a:t>‹#›</a:t>
+            </a:fld>
+            <a:endParaRPr/>
           </a:p>
         </p:txBody>
       </p:sp>
@@ -1208,12 +1247,12 @@
   <p:clrMapOvr>
     <a:masterClrMapping/>
   </p:clrMapOvr>
-  <p:transition xmlns:p14="http://schemas.microsoft.com/office/powerpoint/2010/main" spd="med" advClick="1"/>
+  <p:transition spd="med"/>
 </p:sldLayout>
 </file>
 
 <file path=ppt/slideLayouts/slideLayout5.xml><?xml version="1.0" encoding="utf-8"?>
-<p:sldLayout xmlns:a="http://schemas.openxmlformats.org/drawingml/2006/main" xmlns:r="http://schemas.openxmlformats.org/officeDocument/2006/relationships" xmlns:p="http://schemas.openxmlformats.org/presentationml/2006/main" xmlns:m="http://schemas.openxmlformats.org/officeDocument/2006/math" xmlns:a14="http://schemas.microsoft.com/office/drawing/2010/main" type="tx" showMasterSp="1" showMasterPhAnim="1">
+<p:sldLayout xmlns:a="http://schemas.openxmlformats.org/drawingml/2006/main" xmlns:r="http://schemas.openxmlformats.org/officeDocument/2006/relationships" xmlns:p="http://schemas.openxmlformats.org/presentationml/2006/main" type="tx">
   <p:cSld name="自訂版面配置">
     <p:spTree>
       <p:nvGrpSpPr>
@@ -1232,7 +1271,9 @@
       <p:sp>
         <p:nvSpPr>
           <p:cNvPr id="49" name="大標題文字"/>
-          <p:cNvSpPr txBox="1"/>
+          <p:cNvSpPr txBox="1">
+            <a:spLocks noGrp="1"/>
+          </p:cNvSpPr>
           <p:nvPr>
             <p:ph type="title"/>
           </p:nvPr>
@@ -1261,7 +1302,6 @@
             </a:lvl1pPr>
           </a:lstStyle>
           <a:p>
-            <a:pPr/>
             <a:r>
               <a:t>大標題文字</a:t>
             </a:r>
@@ -1271,7 +1311,9 @@
       <p:sp>
         <p:nvSpPr>
           <p:cNvPr id="50" name="內文層級一…"/>
-          <p:cNvSpPr txBox="1"/>
+          <p:cNvSpPr txBox="1">
+            <a:spLocks noGrp="1"/>
+          </p:cNvSpPr>
           <p:nvPr>
             <p:ph type="body" idx="1"/>
           </p:nvPr>
@@ -1287,39 +1329,39 @@
         </p:spPr>
         <p:txBody>
           <a:bodyPr lIns="45699" tIns="45699" rIns="45699" bIns="45699">
-            <a:normAutofit fontScale="100000" lnSpcReduction="0"/>
+            <a:normAutofit/>
           </a:bodyPr>
           <a:lstStyle>
             <a:lvl1pPr marL="228600">
-              <a:defRPr b="1" sz="5400">
+              <a:defRPr sz="5400" b="1">
                 <a:solidFill>
                   <a:srgbClr val="FFF2CC"/>
                 </a:solidFill>
               </a:defRPr>
             </a:lvl1pPr>
             <a:lvl2pPr marL="228600" indent="457200">
-              <a:defRPr b="1" sz="5400">
+              <a:defRPr sz="5400" b="1">
                 <a:solidFill>
                   <a:srgbClr val="FFF2CC"/>
                 </a:solidFill>
               </a:defRPr>
             </a:lvl2pPr>
             <a:lvl3pPr marL="228600" indent="914400">
-              <a:defRPr b="1" sz="5400">
+              <a:defRPr sz="5400" b="1">
                 <a:solidFill>
                   <a:srgbClr val="FFF2CC"/>
                 </a:solidFill>
               </a:defRPr>
             </a:lvl3pPr>
             <a:lvl4pPr marL="228600" indent="1371600">
-              <a:defRPr b="1" sz="5400">
+              <a:defRPr sz="5400" b="1">
                 <a:solidFill>
                   <a:srgbClr val="FFF2CC"/>
                 </a:solidFill>
               </a:defRPr>
             </a:lvl4pPr>
             <a:lvl5pPr marL="228600" indent="1828800">
-              <a:defRPr b="1" sz="5400">
+              <a:defRPr sz="5400" b="1">
                 <a:solidFill>
                   <a:srgbClr val="FFF2CC"/>
                 </a:solidFill>
@@ -1327,7 +1369,6 @@
             </a:lvl5pPr>
           </a:lstStyle>
           <a:p>
-            <a:pPr/>
             <a:r>
               <a:t>內文層級一</a:t>
             </a:r>
@@ -1361,7 +1402,9 @@
       <p:sp>
         <p:nvSpPr>
           <p:cNvPr id="51" name="幻燈片編號"/>
-          <p:cNvSpPr txBox="1"/>
+          <p:cNvSpPr txBox="1">
+            <a:spLocks noGrp="1"/>
+          </p:cNvSpPr>
           <p:nvPr>
             <p:ph type="sldNum" sz="quarter" idx="2"/>
           </p:nvPr>
@@ -1375,8 +1418,10 @@
           <a:bodyPr/>
           <a:lstStyle/>
           <a:p>
-            <a:pPr/>
-            <a:fld id="{86CB4B4D-7CA3-9044-876B-883B54F8677D}" type="slidenum"/>
+            <a:fld id="{86CB4B4D-7CA3-9044-876B-883B54F8677D}" type="slidenum">
+              <a:t>‹#›</a:t>
+            </a:fld>
+            <a:endParaRPr/>
           </a:p>
         </p:txBody>
       </p:sp>
@@ -1385,12 +1430,12 @@
   <p:clrMapOvr>
     <a:masterClrMapping/>
   </p:clrMapOvr>
-  <p:transition xmlns:p14="http://schemas.microsoft.com/office/powerpoint/2010/main" spd="med" advClick="1"/>
+  <p:transition spd="med"/>
 </p:sldLayout>
 </file>
 
 <file path=ppt/slideLayouts/slideLayout6.xml><?xml version="1.0" encoding="utf-8"?>
-<p:sldLayout xmlns:a="http://schemas.openxmlformats.org/drawingml/2006/main" xmlns:r="http://schemas.openxmlformats.org/officeDocument/2006/relationships" xmlns:p="http://schemas.openxmlformats.org/presentationml/2006/main" xmlns:m="http://schemas.openxmlformats.org/officeDocument/2006/math" xmlns:a14="http://schemas.microsoft.com/office/drawing/2010/main" type="tx" showMasterSp="1" showMasterPhAnim="1">
+<p:sldLayout xmlns:a="http://schemas.openxmlformats.org/drawingml/2006/main" xmlns:r="http://schemas.openxmlformats.org/officeDocument/2006/relationships" xmlns:p="http://schemas.openxmlformats.org/presentationml/2006/main" type="tx">
   <p:cSld name="標題投影片">
     <p:spTree>
       <p:nvGrpSpPr>
@@ -1409,7 +1454,9 @@
       <p:sp>
         <p:nvSpPr>
           <p:cNvPr id="58" name="大標題文字"/>
-          <p:cNvSpPr txBox="1"/>
+          <p:cNvSpPr txBox="1">
+            <a:spLocks noGrp="1"/>
+          </p:cNvSpPr>
           <p:nvPr>
             <p:ph type="title"/>
           </p:nvPr>
@@ -1431,7 +1478,6 @@
             </a:lvl1pPr>
           </a:lstStyle>
           <a:p>
-            <a:pPr/>
             <a:r>
               <a:t>大標題文字</a:t>
             </a:r>
@@ -1441,7 +1487,9 @@
       <p:sp>
         <p:nvSpPr>
           <p:cNvPr id="59" name="內文層級一…"/>
-          <p:cNvSpPr txBox="1"/>
+          <p:cNvSpPr txBox="1">
+            <a:spLocks noGrp="1"/>
+          </p:cNvSpPr>
           <p:nvPr>
             <p:ph type="body" sz="half" idx="1"/>
           </p:nvPr>
@@ -1457,14 +1505,14 @@
         </p:spPr>
         <p:txBody>
           <a:bodyPr lIns="45699" tIns="45699" rIns="45699" bIns="45699">
-            <a:normAutofit fontScale="100000" lnSpcReduction="0"/>
+            <a:normAutofit/>
           </a:bodyPr>
           <a:lstStyle>
             <a:lvl1pPr marL="228600">
               <a:lnSpc>
                 <a:spcPct val="110000"/>
               </a:lnSpc>
-              <a:defRPr b="1" sz="4000">
+              <a:defRPr sz="4000" b="1">
                 <a:solidFill>
                   <a:srgbClr val="FFFFFF"/>
                 </a:solidFill>
@@ -1474,7 +1522,7 @@
               <a:lnSpc>
                 <a:spcPct val="110000"/>
               </a:lnSpc>
-              <a:defRPr b="1" sz="4000">
+              <a:defRPr sz="4000" b="1">
                 <a:solidFill>
                   <a:srgbClr val="FFFFFF"/>
                 </a:solidFill>
@@ -1484,7 +1532,7 @@
               <a:lnSpc>
                 <a:spcPct val="110000"/>
               </a:lnSpc>
-              <a:defRPr b="1" sz="4000">
+              <a:defRPr sz="4000" b="1">
                 <a:solidFill>
                   <a:srgbClr val="FFFFFF"/>
                 </a:solidFill>
@@ -1494,7 +1542,7 @@
               <a:lnSpc>
                 <a:spcPct val="110000"/>
               </a:lnSpc>
-              <a:defRPr b="1" sz="4000">
+              <a:defRPr sz="4000" b="1">
                 <a:solidFill>
                   <a:srgbClr val="FFFFFF"/>
                 </a:solidFill>
@@ -1504,7 +1552,7 @@
               <a:lnSpc>
                 <a:spcPct val="110000"/>
               </a:lnSpc>
-              <a:defRPr b="1" sz="4000">
+              <a:defRPr sz="4000" b="1">
                 <a:solidFill>
                   <a:srgbClr val="FFFFFF"/>
                 </a:solidFill>
@@ -1512,7 +1560,6 @@
             </a:lvl5pPr>
           </a:lstStyle>
           <a:p>
-            <a:pPr/>
             <a:r>
               <a:t>內文層級一</a:t>
             </a:r>
@@ -1562,7 +1609,7 @@
           </a:ln>
           <a:extLst>
             <a:ext uri="{C572A759-6A51-4108-AA02-DFA0A04FC94B}">
-              <ma14:wrappingTextBoxFlag xmlns:ma14="http://schemas.microsoft.com/office/mac/drawingml/2011/main" val="1"/>
+              <ma14:wrappingTextBoxFlag xmlns:ma14="http://schemas.microsoft.com/office/mac/drawingml/2011/main" xmlns:a14="http://schemas.microsoft.com/office/drawing/2010/main" xmlns:m="http://schemas.openxmlformats.org/officeDocument/2006/math" xmlns="" val="1"/>
             </a:ext>
           </a:extLst>
         </p:spPr>
@@ -1576,7 +1623,7 @@
               <a:lnSpc>
                 <a:spcPct val="110000"/>
               </a:lnSpc>
-              <a:defRPr b="1" sz="4000">
+              <a:defRPr sz="4000" b="1">
                 <a:solidFill>
                   <a:srgbClr val="FFFFFF"/>
                 </a:solidFill>
@@ -1591,7 +1638,7 @@
               <a:lnSpc>
                 <a:spcPct val="110000"/>
               </a:lnSpc>
-              <a:defRPr b="1" sz="4000">
+              <a:defRPr sz="4000" b="1">
                 <a:solidFill>
                   <a:srgbClr val="FFFFFF"/>
                 </a:solidFill>
@@ -1606,7 +1653,9 @@
       <p:sp>
         <p:nvSpPr>
           <p:cNvPr id="61" name="幻燈片編號"/>
-          <p:cNvSpPr txBox="1"/>
+          <p:cNvSpPr txBox="1">
+            <a:spLocks noGrp="1"/>
+          </p:cNvSpPr>
           <p:nvPr>
             <p:ph type="sldNum" sz="quarter" idx="2"/>
           </p:nvPr>
@@ -1620,8 +1669,10 @@
           <a:bodyPr/>
           <a:lstStyle/>
           <a:p>
-            <a:pPr/>
-            <a:fld id="{86CB4B4D-7CA3-9044-876B-883B54F8677D}" type="slidenum"/>
+            <a:fld id="{86CB4B4D-7CA3-9044-876B-883B54F8677D}" type="slidenum">
+              <a:t>‹#›</a:t>
+            </a:fld>
+            <a:endParaRPr/>
           </a:p>
         </p:txBody>
       </p:sp>
@@ -1630,18 +1681,19 @@
   <p:clrMapOvr>
     <a:masterClrMapping/>
   </p:clrMapOvr>
-  <p:transition xmlns:p14="http://schemas.microsoft.com/office/powerpoint/2010/main" spd="med" advClick="1"/>
+  <p:transition spd="med"/>
 </p:sldLayout>
 </file>
 
 <file path=ppt/slideMasters/slideMaster1.xml><?xml version="1.0" encoding="utf-8"?>
-<p:sldMaster xmlns:a="http://schemas.openxmlformats.org/drawingml/2006/main" xmlns:r="http://schemas.openxmlformats.org/officeDocument/2006/relationships" xmlns:p="http://schemas.openxmlformats.org/presentationml/2006/main" xmlns:m="http://schemas.openxmlformats.org/officeDocument/2006/math" xmlns:a14="http://schemas.microsoft.com/office/drawing/2010/main">
+<p:sldMaster xmlns:a="http://schemas.openxmlformats.org/drawingml/2006/main" xmlns:r="http://schemas.openxmlformats.org/officeDocument/2006/relationships" xmlns:p="http://schemas.openxmlformats.org/presentationml/2006/main">
   <p:cSld>
     <p:bg>
       <p:bgPr>
         <a:solidFill>
           <a:srgbClr val="000000"/>
         </a:solidFill>
+        <a:effectLst/>
       </p:bgPr>
     </p:bg>
     <p:spTree>
@@ -1661,7 +1713,9 @@
       <p:sp>
         <p:nvSpPr>
           <p:cNvPr id="2" name="大標題文字"/>
-          <p:cNvSpPr txBox="1"/>
+          <p:cNvSpPr txBox="1">
+            <a:spLocks noGrp="1"/>
+          </p:cNvSpPr>
           <p:nvPr>
             <p:ph type="title"/>
           </p:nvPr>
@@ -1679,17 +1733,16 @@
           </a:ln>
           <a:extLst>
             <a:ext uri="{C572A759-6A51-4108-AA02-DFA0A04FC94B}">
-              <ma14:wrappingTextBoxFlag xmlns:ma14="http://schemas.microsoft.com/office/mac/drawingml/2011/main" val="1"/>
+              <ma14:wrappingTextBoxFlag xmlns:ma14="http://schemas.microsoft.com/office/mac/drawingml/2011/main" xmlns:a14="http://schemas.microsoft.com/office/drawing/2010/main" xmlns:m="http://schemas.openxmlformats.org/officeDocument/2006/math" xmlns="" val="1"/>
             </a:ext>
           </a:extLst>
         </p:spPr>
         <p:txBody>
           <a:bodyPr lIns="45699" tIns="45699" rIns="45699" bIns="45699" anchor="ctr">
-            <a:normAutofit fontScale="100000" lnSpcReduction="0"/>
+            <a:normAutofit/>
           </a:bodyPr>
           <a:lstStyle/>
           <a:p>
-            <a:pPr/>
             <a:r>
               <a:t>大標題文字</a:t>
             </a:r>
@@ -1699,7 +1752,9 @@
       <p:sp>
         <p:nvSpPr>
           <p:cNvPr id="3" name="內文層級一…"/>
-          <p:cNvSpPr txBox="1"/>
+          <p:cNvSpPr txBox="1">
+            <a:spLocks noGrp="1"/>
+          </p:cNvSpPr>
           <p:nvPr>
             <p:ph type="body" idx="1"/>
           </p:nvPr>
@@ -1717,7 +1772,7 @@
           </a:ln>
           <a:extLst>
             <a:ext uri="{C572A759-6A51-4108-AA02-DFA0A04FC94B}">
-              <ma14:wrappingTextBoxFlag xmlns:ma14="http://schemas.microsoft.com/office/mac/drawingml/2011/main" val="1"/>
+              <ma14:wrappingTextBoxFlag xmlns:ma14="http://schemas.microsoft.com/office/mac/drawingml/2011/main" xmlns:a14="http://schemas.microsoft.com/office/drawing/2010/main" xmlns:m="http://schemas.openxmlformats.org/officeDocument/2006/math" xmlns="" val="1"/>
             </a:ext>
           </a:extLst>
         </p:spPr>
@@ -1725,7 +1780,6 @@
           <a:bodyPr lIns="45719" rIns="45719"/>
           <a:lstStyle/>
           <a:p>
-            <a:pPr/>
             <a:r>
               <a:t>內文層級一</a:t>
             </a:r>
@@ -1759,7 +1813,9 @@
       <p:sp>
         <p:nvSpPr>
           <p:cNvPr id="4" name="幻燈片編號"/>
-          <p:cNvSpPr txBox="1"/>
+          <p:cNvSpPr txBox="1">
+            <a:spLocks noGrp="1"/>
+          </p:cNvSpPr>
           <p:nvPr>
             <p:ph type="sldNum" sz="quarter" idx="2"/>
           </p:nvPr>
@@ -1786,8 +1842,10 @@
             </a:lvl1pPr>
           </a:lstStyle>
           <a:p>
-            <a:pPr/>
-            <a:fld id="{86CB4B4D-7CA3-9044-876B-883B54F8677D}" type="slidenum"/>
+            <a:fld id="{86CB4B4D-7CA3-9044-876B-883B54F8677D}" type="slidenum">
+              <a:t>‹#›</a:t>
+            </a:fld>
+            <a:endParaRPr/>
           </a:p>
         </p:txBody>
       </p:sp>
@@ -1795,14 +1853,14 @@
   </p:cSld>
   <p:clrMap bg1="lt1" tx1="dk1" bg2="lt2" tx2="dk2" accent1="accent1" accent2="accent2" accent3="accent3" accent4="accent4" accent5="accent5" accent6="accent6" hlink="hlink" folHlink="folHlink"/>
   <p:sldLayoutIdLst>
-    <p:sldLayoutId id="2147483649" r:id="rId2"/>
-    <p:sldLayoutId id="2147483650" r:id="rId3"/>
-    <p:sldLayoutId id="2147483651" r:id="rId4"/>
-    <p:sldLayoutId id="2147483652" r:id="rId5"/>
-    <p:sldLayoutId id="2147483653" r:id="rId6"/>
-    <p:sldLayoutId id="2147483654" r:id="rId7"/>
+    <p:sldLayoutId id="2147483649" r:id="rId1"/>
+    <p:sldLayoutId id="2147483650" r:id="rId2"/>
+    <p:sldLayoutId id="2147483651" r:id="rId3"/>
+    <p:sldLayoutId id="2147483652" r:id="rId4"/>
+    <p:sldLayoutId id="2147483653" r:id="rId5"/>
+    <p:sldLayoutId id="2147483654" r:id="rId6"/>
   </p:sldLayoutIdLst>
-  <p:transition xmlns:p14="http://schemas.microsoft.com/office/powerpoint/2010/main" spd="med" advClick="1"/>
+  <p:transition spd="med"/>
   <p:txStyles>
     <p:titleStyle>
       <a:lvl1pPr marL="0" marR="0" indent="0" algn="l" defTabSz="914400" rtl="0" latinLnBrk="0">
@@ -1820,7 +1878,7 @@
         <a:buFontTx/>
         <a:buNone/>
         <a:tabLst/>
-        <a:defRPr b="1" baseline="0" cap="none" i="0" spc="0" strike="noStrike" sz="6000" u="none">
+        <a:defRPr sz="6000" b="1" i="0" u="none" strike="noStrike" cap="none" spc="0" baseline="0">
           <a:solidFill>
             <a:srgbClr val="FFFFFF"/>
           </a:solidFill>
@@ -1846,7 +1904,7 @@
         <a:buFontTx/>
         <a:buNone/>
         <a:tabLst/>
-        <a:defRPr b="1" baseline="0" cap="none" i="0" spc="0" strike="noStrike" sz="6000" u="none">
+        <a:defRPr sz="6000" b="1" i="0" u="none" strike="noStrike" cap="none" spc="0" baseline="0">
           <a:solidFill>
             <a:srgbClr val="FFFFFF"/>
           </a:solidFill>
@@ -1872,7 +1930,7 @@
         <a:buFontTx/>
         <a:buNone/>
         <a:tabLst/>
-        <a:defRPr b="1" baseline="0" cap="none" i="0" spc="0" strike="noStrike" sz="6000" u="none">
+        <a:defRPr sz="6000" b="1" i="0" u="none" strike="noStrike" cap="none" spc="0" baseline="0">
           <a:solidFill>
             <a:srgbClr val="FFFFFF"/>
           </a:solidFill>
@@ -1898,7 +1956,7 @@
         <a:buFontTx/>
         <a:buNone/>
         <a:tabLst/>
-        <a:defRPr b="1" baseline="0" cap="none" i="0" spc="0" strike="noStrike" sz="6000" u="none">
+        <a:defRPr sz="6000" b="1" i="0" u="none" strike="noStrike" cap="none" spc="0" baseline="0">
           <a:solidFill>
             <a:srgbClr val="FFFFFF"/>
           </a:solidFill>
@@ -1924,7 +1982,7 @@
         <a:buFontTx/>
         <a:buNone/>
         <a:tabLst/>
-        <a:defRPr b="1" baseline="0" cap="none" i="0" spc="0" strike="noStrike" sz="6000" u="none">
+        <a:defRPr sz="6000" b="1" i="0" u="none" strike="noStrike" cap="none" spc="0" baseline="0">
           <a:solidFill>
             <a:srgbClr val="FFFFFF"/>
           </a:solidFill>
@@ -1950,7 +2008,7 @@
         <a:buFontTx/>
         <a:buNone/>
         <a:tabLst/>
-        <a:defRPr b="1" baseline="0" cap="none" i="0" spc="0" strike="noStrike" sz="6000" u="none">
+        <a:defRPr sz="6000" b="1" i="0" u="none" strike="noStrike" cap="none" spc="0" baseline="0">
           <a:solidFill>
             <a:srgbClr val="FFFFFF"/>
           </a:solidFill>
@@ -1976,7 +2034,7 @@
         <a:buFontTx/>
         <a:buNone/>
         <a:tabLst/>
-        <a:defRPr b="1" baseline="0" cap="none" i="0" spc="0" strike="noStrike" sz="6000" u="none">
+        <a:defRPr sz="6000" b="1" i="0" u="none" strike="noStrike" cap="none" spc="0" baseline="0">
           <a:solidFill>
             <a:srgbClr val="FFFFFF"/>
           </a:solidFill>
@@ -2002,7 +2060,7 @@
         <a:buFontTx/>
         <a:buNone/>
         <a:tabLst/>
-        <a:defRPr b="1" baseline="0" cap="none" i="0" spc="0" strike="noStrike" sz="6000" u="none">
+        <a:defRPr sz="6000" b="1" i="0" u="none" strike="noStrike" cap="none" spc="0" baseline="0">
           <a:solidFill>
             <a:srgbClr val="FFFFFF"/>
           </a:solidFill>
@@ -2028,7 +2086,7 @@
         <a:buFontTx/>
         <a:buNone/>
         <a:tabLst/>
-        <a:defRPr b="1" baseline="0" cap="none" i="0" spc="0" strike="noStrike" sz="6000" u="none">
+        <a:defRPr sz="6000" b="1" i="0" u="none" strike="noStrike" cap="none" spc="0" baseline="0">
           <a:solidFill>
             <a:srgbClr val="FFFFFF"/>
           </a:solidFill>
@@ -2056,7 +2114,7 @@
         <a:buFontTx/>
         <a:buNone/>
         <a:tabLst/>
-        <a:defRPr b="0" baseline="0" cap="none" i="0" spc="0" strike="noStrike" sz="1400" u="none">
+        <a:defRPr sz="1400" b="0" i="0" u="none" strike="noStrike" cap="none" spc="0" baseline="0">
           <a:solidFill>
             <a:srgbClr val="000000"/>
           </a:solidFill>
@@ -2082,7 +2140,7 @@
         <a:buFontTx/>
         <a:buNone/>
         <a:tabLst/>
-        <a:defRPr b="0" baseline="0" cap="none" i="0" spc="0" strike="noStrike" sz="1400" u="none">
+        <a:defRPr sz="1400" b="0" i="0" u="none" strike="noStrike" cap="none" spc="0" baseline="0">
           <a:solidFill>
             <a:srgbClr val="000000"/>
           </a:solidFill>
@@ -2108,7 +2166,7 @@
         <a:buFontTx/>
         <a:buNone/>
         <a:tabLst/>
-        <a:defRPr b="0" baseline="0" cap="none" i="0" spc="0" strike="noStrike" sz="1400" u="none">
+        <a:defRPr sz="1400" b="0" i="0" u="none" strike="noStrike" cap="none" spc="0" baseline="0">
           <a:solidFill>
             <a:srgbClr val="000000"/>
           </a:solidFill>
@@ -2134,7 +2192,7 @@
         <a:buFontTx/>
         <a:buNone/>
         <a:tabLst/>
-        <a:defRPr b="0" baseline="0" cap="none" i="0" spc="0" strike="noStrike" sz="1400" u="none">
+        <a:defRPr sz="1400" b="0" i="0" u="none" strike="noStrike" cap="none" spc="0" baseline="0">
           <a:solidFill>
             <a:srgbClr val="000000"/>
           </a:solidFill>
@@ -2160,7 +2218,7 @@
         <a:buFontTx/>
         <a:buNone/>
         <a:tabLst/>
-        <a:defRPr b="0" baseline="0" cap="none" i="0" spc="0" strike="noStrike" sz="1400" u="none">
+        <a:defRPr sz="1400" b="0" i="0" u="none" strike="noStrike" cap="none" spc="0" baseline="0">
           <a:solidFill>
             <a:srgbClr val="000000"/>
           </a:solidFill>
@@ -2186,7 +2244,7 @@
         <a:buFontTx/>
         <a:buNone/>
         <a:tabLst/>
-        <a:defRPr b="0" baseline="0" cap="none" i="0" spc="0" strike="noStrike" sz="1400" u="none">
+        <a:defRPr sz="1400" b="0" i="0" u="none" strike="noStrike" cap="none" spc="0" baseline="0">
           <a:solidFill>
             <a:srgbClr val="000000"/>
           </a:solidFill>
@@ -2212,7 +2270,7 @@
         <a:buFontTx/>
         <a:buNone/>
         <a:tabLst/>
-        <a:defRPr b="0" baseline="0" cap="none" i="0" spc="0" strike="noStrike" sz="1400" u="none">
+        <a:defRPr sz="1400" b="0" i="0" u="none" strike="noStrike" cap="none" spc="0" baseline="0">
           <a:solidFill>
             <a:srgbClr val="000000"/>
           </a:solidFill>
@@ -2238,7 +2296,7 @@
         <a:buFontTx/>
         <a:buNone/>
         <a:tabLst/>
-        <a:defRPr b="0" baseline="0" cap="none" i="0" spc="0" strike="noStrike" sz="1400" u="none">
+        <a:defRPr sz="1400" b="0" i="0" u="none" strike="noStrike" cap="none" spc="0" baseline="0">
           <a:solidFill>
             <a:srgbClr val="000000"/>
           </a:solidFill>
@@ -2264,7 +2322,7 @@
         <a:buFontTx/>
         <a:buNone/>
         <a:tabLst/>
-        <a:defRPr b="0" baseline="0" cap="none" i="0" spc="0" strike="noStrike" sz="1400" u="none">
+        <a:defRPr sz="1400" b="0" i="0" u="none" strike="noStrike" cap="none" spc="0" baseline="0">
           <a:solidFill>
             <a:srgbClr val="000000"/>
           </a:solidFill>
@@ -2292,7 +2350,7 @@
         <a:buFontTx/>
         <a:buNone/>
         <a:tabLst/>
-        <a:defRPr b="0" baseline="0" cap="none" i="0" spc="0" strike="noStrike" sz="1200" u="none">
+        <a:defRPr sz="1200" b="0" i="0" u="none" strike="noStrike" cap="none" spc="0" baseline="0">
           <a:solidFill>
             <a:schemeClr val="tx1"/>
           </a:solidFill>
@@ -2318,7 +2376,7 @@
         <a:buFontTx/>
         <a:buNone/>
         <a:tabLst/>
-        <a:defRPr b="0" baseline="0" cap="none" i="0" spc="0" strike="noStrike" sz="1200" u="none">
+        <a:defRPr sz="1200" b="0" i="0" u="none" strike="noStrike" cap="none" spc="0" baseline="0">
           <a:solidFill>
             <a:schemeClr val="tx1"/>
           </a:solidFill>
@@ -2344,7 +2402,7 @@
         <a:buFontTx/>
         <a:buNone/>
         <a:tabLst/>
-        <a:defRPr b="0" baseline="0" cap="none" i="0" spc="0" strike="noStrike" sz="1200" u="none">
+        <a:defRPr sz="1200" b="0" i="0" u="none" strike="noStrike" cap="none" spc="0" baseline="0">
           <a:solidFill>
             <a:schemeClr val="tx1"/>
           </a:solidFill>
@@ -2370,7 +2428,7 @@
         <a:buFontTx/>
         <a:buNone/>
         <a:tabLst/>
-        <a:defRPr b="0" baseline="0" cap="none" i="0" spc="0" strike="noStrike" sz="1200" u="none">
+        <a:defRPr sz="1200" b="0" i="0" u="none" strike="noStrike" cap="none" spc="0" baseline="0">
           <a:solidFill>
             <a:schemeClr val="tx1"/>
           </a:solidFill>
@@ -2396,7 +2454,7 @@
         <a:buFontTx/>
         <a:buNone/>
         <a:tabLst/>
-        <a:defRPr b="0" baseline="0" cap="none" i="0" spc="0" strike="noStrike" sz="1200" u="none">
+        <a:defRPr sz="1200" b="0" i="0" u="none" strike="noStrike" cap="none" spc="0" baseline="0">
           <a:solidFill>
             <a:schemeClr val="tx1"/>
           </a:solidFill>
@@ -2422,7 +2480,7 @@
         <a:buFontTx/>
         <a:buNone/>
         <a:tabLst/>
-        <a:defRPr b="0" baseline="0" cap="none" i="0" spc="0" strike="noStrike" sz="1200" u="none">
+        <a:defRPr sz="1200" b="0" i="0" u="none" strike="noStrike" cap="none" spc="0" baseline="0">
           <a:solidFill>
             <a:schemeClr val="tx1"/>
           </a:solidFill>
@@ -2448,7 +2506,7 @@
         <a:buFontTx/>
         <a:buNone/>
         <a:tabLst/>
-        <a:defRPr b="0" baseline="0" cap="none" i="0" spc="0" strike="noStrike" sz="1200" u="none">
+        <a:defRPr sz="1200" b="0" i="0" u="none" strike="noStrike" cap="none" spc="0" baseline="0">
           <a:solidFill>
             <a:schemeClr val="tx1"/>
           </a:solidFill>
@@ -2474,7 +2532,7 @@
         <a:buFontTx/>
         <a:buNone/>
         <a:tabLst/>
-        <a:defRPr b="0" baseline="0" cap="none" i="0" spc="0" strike="noStrike" sz="1200" u="none">
+        <a:defRPr sz="1200" b="0" i="0" u="none" strike="noStrike" cap="none" spc="0" baseline="0">
           <a:solidFill>
             <a:schemeClr val="tx1"/>
           </a:solidFill>
@@ -2500,7 +2558,7 @@
         <a:buFontTx/>
         <a:buNone/>
         <a:tabLst/>
-        <a:defRPr b="0" baseline="0" cap="none" i="0" spc="0" strike="noStrike" sz="1200" u="none">
+        <a:defRPr sz="1200" b="0" i="0" u="none" strike="noStrike" cap="none" spc="0" baseline="0">
           <a:solidFill>
             <a:schemeClr val="tx1"/>
           </a:solidFill>
@@ -2517,7 +2575,7 @@
 </file>
 
 <file path=ppt/slides/slide1.xml><?xml version="1.0" encoding="utf-8"?>
-<p:sld xmlns:a="http://schemas.openxmlformats.org/drawingml/2006/main" xmlns:r="http://schemas.openxmlformats.org/officeDocument/2006/relationships" xmlns:p="http://schemas.openxmlformats.org/presentationml/2006/main" xmlns:m="http://schemas.openxmlformats.org/officeDocument/2006/math" xmlns:a14="http://schemas.microsoft.com/office/drawing/2010/main" showMasterSp="1" showMasterPhAnim="1">
+<p:sld xmlns:a="http://schemas.openxmlformats.org/drawingml/2006/main" xmlns:r="http://schemas.openxmlformats.org/officeDocument/2006/relationships" xmlns:p="http://schemas.openxmlformats.org/presentationml/2006/main">
   <p:cSld>
     <p:spTree>
       <p:nvGrpSpPr>
@@ -2536,7 +2594,9 @@
       <p:sp>
         <p:nvSpPr>
           <p:cNvPr id="70" name="Google Shape;40;p9"/>
-          <p:cNvSpPr txBox="1"/>
+          <p:cNvSpPr txBox="1">
+            <a:spLocks noGrp="1"/>
+          </p:cNvSpPr>
           <p:nvPr>
             <p:ph type="body" sz="quarter" idx="1"/>
           </p:nvPr>
@@ -2556,8 +2616,11 @@
             <a:lvl1pPr marL="0"/>
           </a:lstStyle>
           <a:p>
-            <a:pPr/>
             <a:r>
+              <a:rPr dirty="0">
+                <a:latin typeface="DFYuanBold-B5" panose="020F0709000000000000" pitchFamily="49" charset="-120"/>
+                <a:ea typeface="DFYuanBold-B5" panose="020F0709000000000000" pitchFamily="49" charset="-120"/>
+              </a:rPr>
               <a:t>11</a:t>
             </a:r>
           </a:p>
@@ -2566,7 +2629,9 @@
       <p:sp>
         <p:nvSpPr>
           <p:cNvPr id="71" name="Google Shape;41;p9"/>
-          <p:cNvSpPr txBox="1"/>
+          <p:cNvSpPr txBox="1">
+            <a:spLocks noGrp="1"/>
+          </p:cNvSpPr>
           <p:nvPr>
             <p:ph type="title"/>
           </p:nvPr>
@@ -2588,9 +2653,23 @@
             </a:lvl1pPr>
           </a:lstStyle>
           <a:p>
-            <a:pPr/>
             <a:r>
-              <a:t>撒母耳記下 1:11-14</a:t>
+              <a:rPr dirty="0" err="1">
+                <a:latin typeface="DFYuanBold-B5" panose="020F0709000000000000" pitchFamily="49" charset="-120"/>
+                <a:ea typeface="DFYuanBold-B5" panose="020F0709000000000000" pitchFamily="49" charset="-120"/>
+              </a:rPr>
+              <a:t>撒母耳記下</a:t>
+            </a:r>
+            <a:r>
+              <a:rPr dirty="0"/>
+              <a:t> </a:t>
+            </a:r>
+            <a:r>
+              <a:rPr dirty="0">
+                <a:latin typeface="DFYuanBold-B5" panose="020F0709000000000000" pitchFamily="49" charset="-120"/>
+                <a:ea typeface="DFYuanBold-B5" panose="020F0709000000000000" pitchFamily="49" charset="-120"/>
+              </a:rPr>
+              <a:t>1:11-14</a:t>
             </a:r>
           </a:p>
         </p:txBody>
@@ -2598,7 +2677,9 @@
       <p:sp>
         <p:nvSpPr>
           <p:cNvPr id="72" name="Google Shape;42;p9"/>
-          <p:cNvSpPr txBox="1"/>
+          <p:cNvSpPr txBox="1">
+            <a:spLocks noGrp="1"/>
+          </p:cNvSpPr>
           <p:nvPr>
             <p:ph type="body" idx="21"/>
           </p:nvPr>
@@ -2609,7 +2690,7 @@
           </a:prstGeom>
           <a:extLst>
             <a:ext uri="{C572A759-6A51-4108-AA02-DFA0A04FC94B}">
-              <ma14:wrappingTextBoxFlag xmlns:ma14="http://schemas.microsoft.com/office/mac/drawingml/2011/main" val="1"/>
+              <ma14:wrappingTextBoxFlag xmlns:ma14="http://schemas.microsoft.com/office/mac/drawingml/2011/main" xmlns:a14="http://schemas.microsoft.com/office/drawing/2010/main" xmlns:m="http://schemas.openxmlformats.org/officeDocument/2006/math" xmlns="" val="1"/>
             </a:ext>
           </a:extLst>
         </p:spPr>
@@ -2617,7 +2698,7 @@
           <a:bodyPr/>
           <a:lstStyle>
             <a:lvl1pPr>
-              <a:defRPr b="1" sz="5400">
+              <a:defRPr sz="5400" b="1">
                 <a:solidFill>
                   <a:srgbClr val="FFFFFF"/>
                 </a:solidFill>
@@ -2625,9 +2706,19 @@
             </a:lvl1pPr>
           </a:lstStyle>
           <a:p>
-            <a:pPr/>
             <a:r>
-              <a:t>大衛就撕裂衣服，跟隨他的人也是如此，</a:t>
+              <a:rPr dirty="0" err="1">
+                <a:latin typeface="DFYuanBold-B5" panose="020F0709000000000000" pitchFamily="49" charset="-120"/>
+                <a:ea typeface="DFYuanBold-B5" panose="020F0709000000000000" pitchFamily="49" charset="-120"/>
+              </a:rPr>
+              <a:t>大衛就撕裂衣服，跟隨他的人也是如此</a:t>
+            </a:r>
+            <a:r>
+              <a:rPr dirty="0">
+                <a:latin typeface="DFYuanBold-B5" panose="020F0709000000000000" pitchFamily="49" charset="-120"/>
+                <a:ea typeface="DFYuanBold-B5" panose="020F0709000000000000" pitchFamily="49" charset="-120"/>
+              </a:rPr>
+              <a:t>，</a:t>
             </a:r>
           </a:p>
         </p:txBody>
@@ -2635,7 +2726,9 @@
       <p:sp>
         <p:nvSpPr>
           <p:cNvPr id="73" name="Google Shape;43;p9"/>
-          <p:cNvSpPr txBox="1"/>
+          <p:cNvSpPr txBox="1">
+            <a:spLocks noGrp="1"/>
+          </p:cNvSpPr>
           <p:nvPr>
             <p:ph type="body" idx="22"/>
           </p:nvPr>
@@ -2646,7 +2739,7 @@
           </a:prstGeom>
           <a:extLst>
             <a:ext uri="{C572A759-6A51-4108-AA02-DFA0A04FC94B}">
-              <ma14:wrappingTextBoxFlag xmlns:ma14="http://schemas.microsoft.com/office/mac/drawingml/2011/main" val="1"/>
+              <ma14:wrappingTextBoxFlag xmlns:ma14="http://schemas.microsoft.com/office/mac/drawingml/2011/main" xmlns:a14="http://schemas.microsoft.com/office/drawing/2010/main" xmlns:m="http://schemas.openxmlformats.org/officeDocument/2006/math" xmlns="" val="1"/>
             </a:ext>
           </a:extLst>
         </p:spPr>
@@ -2654,7 +2747,7 @@
           <a:bodyPr/>
           <a:lstStyle>
             <a:lvl1pPr defTabSz="832104">
-              <a:defRPr b="1" sz="3640">
+              <a:defRPr sz="3640" b="1">
                 <a:solidFill>
                   <a:srgbClr val="FBE4D4"/>
                 </a:solidFill>
@@ -2662,9 +2755,26 @@
             </a:lvl1pPr>
           </a:lstStyle>
           <a:p>
-            <a:pPr/>
             <a:r>
-              <a:t>(和合本修訂版RCUV)</a:t>
+              <a:rPr dirty="0">
+                <a:latin typeface="DFYuanBold-B5" panose="020F0709000000000000" pitchFamily="49" charset="-120"/>
+                <a:ea typeface="DFYuanBold-B5" panose="020F0709000000000000" pitchFamily="49" charset="-120"/>
+              </a:rPr>
+              <a:t>(</a:t>
+            </a:r>
+            <a:r>
+              <a:rPr dirty="0" err="1">
+                <a:latin typeface="DFYuanBold-B5" panose="020F0709000000000000" pitchFamily="49" charset="-120"/>
+                <a:ea typeface="DFYuanBold-B5" panose="020F0709000000000000" pitchFamily="49" charset="-120"/>
+              </a:rPr>
+              <a:t>和合本修訂版RCUV</a:t>
+            </a:r>
+            <a:r>
+              <a:rPr dirty="0">
+                <a:latin typeface="DFYuanBold-B5" panose="020F0709000000000000" pitchFamily="49" charset="-120"/>
+                <a:ea typeface="DFYuanBold-B5" panose="020F0709000000000000" pitchFamily="49" charset="-120"/>
+              </a:rPr>
+              <a:t>)</a:t>
             </a:r>
           </a:p>
         </p:txBody>
@@ -2674,12 +2784,12 @@
   <p:clrMapOvr>
     <a:masterClrMapping/>
   </p:clrMapOvr>
-  <p:transition xmlns:p14="http://schemas.microsoft.com/office/powerpoint/2010/main" spd="med" advClick="1"/>
+  <p:transition spd="med"/>
 </p:sld>
 </file>
 
 <file path=ppt/theme/theme1.xml><?xml version="1.0" encoding="utf-8"?>
-<a:theme xmlns:a="http://schemas.openxmlformats.org/drawingml/2006/main" xmlns:r="http://schemas.openxmlformats.org/officeDocument/2006/relationships" name="佈景主題1">
+<a:theme xmlns:a="http://schemas.openxmlformats.org/drawingml/2006/main" name="佈景主題1">
   <a:themeElements>
     <a:clrScheme name="佈景主題1">
       <a:dk1>
@@ -2811,7 +2921,7 @@
         </a:effectStyle>
         <a:effectStyle>
           <a:effectLst>
-            <a:outerShdw sx="100000" sy="100000" kx="0" ky="0" algn="b" rotWithShape="0" blurRad="38100" dist="20000" dir="5400000">
+            <a:outerShdw blurRad="38100" dist="20000" dir="5400000" rotWithShape="0">
               <a:srgbClr val="000000">
                 <a:alpha val="38000"/>
               </a:srgbClr>
@@ -2887,7 +2997,7 @@
         <a:effectLst/>
         <a:sp3d/>
       </a:spPr>
-      <a:bodyPr rot="0" spcFirstLastPara="1" vertOverflow="overflow" horzOverflow="overflow" vert="horz" wrap="square" lIns="0" tIns="0" rIns="0" bIns="0" numCol="1" spcCol="38100" rtlCol="0" anchor="t" upright="0">
+      <a:bodyPr rot="0" spcFirstLastPara="1" vertOverflow="overflow" horzOverflow="overflow" vert="horz" wrap="square" lIns="0" tIns="0" rIns="0" bIns="0" numCol="1" spcCol="38100" rtlCol="0" anchor="t">
         <a:spAutoFit/>
       </a:bodyPr>
       <a:lstStyle>
@@ -2906,7 +3016,7 @@
           <a:buFontTx/>
           <a:buNone/>
           <a:tabLst/>
-          <a:defRPr b="0" baseline="0" cap="none" i="0" spc="0" strike="noStrike" sz="1400" u="none" kumimoji="0" normalizeH="0">
+          <a:defRPr kumimoji="0" sz="1400" b="0" i="0" u="none" strike="noStrike" cap="none" spc="0" normalizeH="0" baseline="0">
             <a:ln>
               <a:noFill/>
             </a:ln>
@@ -2936,7 +3046,7 @@
           <a:buFontTx/>
           <a:buNone/>
           <a:tabLst/>
-          <a:defRPr b="0" baseline="0" cap="none" i="0" spc="0" strike="noStrike" sz="1800" u="none" kumimoji="0" normalizeH="0">
+          <a:defRPr kumimoji="0" sz="1800" b="0" i="0" u="none" strike="noStrike" cap="none" spc="0" normalizeH="0" baseline="0">
             <a:ln>
               <a:noFill/>
             </a:ln>
@@ -2962,7 +3072,7 @@
           <a:buFontTx/>
           <a:buNone/>
           <a:tabLst/>
-          <a:defRPr b="0" baseline="0" cap="none" i="0" spc="0" strike="noStrike" sz="1800" u="none" kumimoji="0" normalizeH="0">
+          <a:defRPr kumimoji="0" sz="1800" b="0" i="0" u="none" strike="noStrike" cap="none" spc="0" normalizeH="0" baseline="0">
             <a:ln>
               <a:noFill/>
             </a:ln>
@@ -2988,7 +3098,7 @@
           <a:buFontTx/>
           <a:buNone/>
           <a:tabLst/>
-          <a:defRPr b="0" baseline="0" cap="none" i="0" spc="0" strike="noStrike" sz="1800" u="none" kumimoji="0" normalizeH="0">
+          <a:defRPr kumimoji="0" sz="1800" b="0" i="0" u="none" strike="noStrike" cap="none" spc="0" normalizeH="0" baseline="0">
             <a:ln>
               <a:noFill/>
             </a:ln>
@@ -3014,7 +3124,7 @@
           <a:buFontTx/>
           <a:buNone/>
           <a:tabLst/>
-          <a:defRPr b="0" baseline="0" cap="none" i="0" spc="0" strike="noStrike" sz="1800" u="none" kumimoji="0" normalizeH="0">
+          <a:defRPr kumimoji="0" sz="1800" b="0" i="0" u="none" strike="noStrike" cap="none" spc="0" normalizeH="0" baseline="0">
             <a:ln>
               <a:noFill/>
             </a:ln>
@@ -3040,7 +3150,7 @@
           <a:buFontTx/>
           <a:buNone/>
           <a:tabLst/>
-          <a:defRPr b="0" baseline="0" cap="none" i="0" spc="0" strike="noStrike" sz="1800" u="none" kumimoji="0" normalizeH="0">
+          <a:defRPr kumimoji="0" sz="1800" b="0" i="0" u="none" strike="noStrike" cap="none" spc="0" normalizeH="0" baseline="0">
             <a:ln>
               <a:noFill/>
             </a:ln>
@@ -3066,7 +3176,7 @@
           <a:buFontTx/>
           <a:buNone/>
           <a:tabLst/>
-          <a:defRPr b="0" baseline="0" cap="none" i="0" spc="0" strike="noStrike" sz="1800" u="none" kumimoji="0" normalizeH="0">
+          <a:defRPr kumimoji="0" sz="1800" b="0" i="0" u="none" strike="noStrike" cap="none" spc="0" normalizeH="0" baseline="0">
             <a:ln>
               <a:noFill/>
             </a:ln>
@@ -3092,7 +3202,7 @@
           <a:buFontTx/>
           <a:buNone/>
           <a:tabLst/>
-          <a:defRPr b="0" baseline="0" cap="none" i="0" spc="0" strike="noStrike" sz="1800" u="none" kumimoji="0" normalizeH="0">
+          <a:defRPr kumimoji="0" sz="1800" b="0" i="0" u="none" strike="noStrike" cap="none" spc="0" normalizeH="0" baseline="0">
             <a:ln>
               <a:noFill/>
             </a:ln>
@@ -3118,7 +3228,7 @@
           <a:buFontTx/>
           <a:buNone/>
           <a:tabLst/>
-          <a:defRPr b="0" baseline="0" cap="none" i="0" spc="0" strike="noStrike" sz="1800" u="none" kumimoji="0" normalizeH="0">
+          <a:defRPr kumimoji="0" sz="1800" b="0" i="0" u="none" strike="noStrike" cap="none" spc="0" normalizeH="0" baseline="0">
             <a:ln>
               <a:noFill/>
             </a:ln>
@@ -3144,7 +3254,7 @@
           <a:buFontTx/>
           <a:buNone/>
           <a:tabLst/>
-          <a:defRPr b="0" baseline="0" cap="none" i="0" spc="0" strike="noStrike" sz="1800" u="none" kumimoji="0" normalizeH="0">
+          <a:defRPr kumimoji="0" sz="1800" b="0" i="0" u="none" strike="noStrike" cap="none" spc="0" normalizeH="0" baseline="0">
             <a:ln>
               <a:noFill/>
             </a:ln>
@@ -3157,9 +3267,15 @@
         </a:lvl9pPr>
       </a:lstStyle>
       <a:style>
-        <a:lnRef idx="0"/>
-        <a:fillRef idx="0"/>
-        <a:effectRef idx="0"/>
+        <a:lnRef idx="0">
+          <a:scrgbClr r="0" g="0" b="0"/>
+        </a:lnRef>
+        <a:fillRef idx="0">
+          <a:scrgbClr r="0" g="0" b="0"/>
+        </a:fillRef>
+        <a:effectRef idx="0">
+          <a:scrgbClr r="0" g="0" b="0"/>
+        </a:effectRef>
         <a:fontRef idx="none"/>
       </a:style>
     </a:spDef>
@@ -3174,7 +3290,7 @@
           <a:round/>
         </a:ln>
         <a:effectLst>
-          <a:outerShdw sx="100000" sy="100000" kx="0" ky="0" algn="b" rotWithShape="0" blurRad="38100" dist="20000" dir="5400000">
+          <a:outerShdw blurRad="38100" dist="20000" dir="5400000" rotWithShape="0">
             <a:srgbClr val="000000">
               <a:alpha val="38000"/>
             </a:srgbClr>
@@ -3182,7 +3298,7 @@
         </a:effectLst>
         <a:sp3d/>
       </a:spPr>
-      <a:bodyPr rot="0" spcFirstLastPara="1" vertOverflow="overflow" horzOverflow="overflow" vert="horz" wrap="square" lIns="91439" tIns="45719" rIns="91439" bIns="45719" numCol="1" spcCol="38100" rtlCol="0" anchor="t" upright="0">
+      <a:bodyPr rot="0" spcFirstLastPara="1" vertOverflow="overflow" horzOverflow="overflow" vert="horz" wrap="square" lIns="91439" tIns="45719" rIns="91439" bIns="45719" numCol="1" spcCol="38100" rtlCol="0" anchor="t">
         <a:noAutofit/>
       </a:bodyPr>
       <a:lstStyle>
@@ -3201,7 +3317,7 @@
           <a:buFontTx/>
           <a:buNone/>
           <a:tabLst/>
-          <a:defRPr b="0" baseline="0" cap="none" i="0" spc="0" strike="noStrike" sz="1800" u="none" kumimoji="0" normalizeH="0">
+          <a:defRPr kumimoji="0" sz="1800" b="0" i="0" u="none" strike="noStrike" cap="none" spc="0" normalizeH="0" baseline="0">
             <a:ln>
               <a:noFill/>
             </a:ln>
@@ -3227,7 +3343,7 @@
           <a:buFontTx/>
           <a:buNone/>
           <a:tabLst/>
-          <a:defRPr b="0" baseline="0" cap="none" i="0" spc="0" strike="noStrike" sz="1800" u="none" kumimoji="0" normalizeH="0">
+          <a:defRPr kumimoji="0" sz="1800" b="0" i="0" u="none" strike="noStrike" cap="none" spc="0" normalizeH="0" baseline="0">
             <a:ln>
               <a:noFill/>
             </a:ln>
@@ -3253,7 +3369,7 @@
           <a:buFontTx/>
           <a:buNone/>
           <a:tabLst/>
-          <a:defRPr b="0" baseline="0" cap="none" i="0" spc="0" strike="noStrike" sz="1800" u="none" kumimoji="0" normalizeH="0">
+          <a:defRPr kumimoji="0" sz="1800" b="0" i="0" u="none" strike="noStrike" cap="none" spc="0" normalizeH="0" baseline="0">
             <a:ln>
               <a:noFill/>
             </a:ln>
@@ -3279,7 +3395,7 @@
           <a:buFontTx/>
           <a:buNone/>
           <a:tabLst/>
-          <a:defRPr b="0" baseline="0" cap="none" i="0" spc="0" strike="noStrike" sz="1800" u="none" kumimoji="0" normalizeH="0">
+          <a:defRPr kumimoji="0" sz="1800" b="0" i="0" u="none" strike="noStrike" cap="none" spc="0" normalizeH="0" baseline="0">
             <a:ln>
               <a:noFill/>
             </a:ln>
@@ -3305,7 +3421,7 @@
           <a:buFontTx/>
           <a:buNone/>
           <a:tabLst/>
-          <a:defRPr b="0" baseline="0" cap="none" i="0" spc="0" strike="noStrike" sz="1800" u="none" kumimoji="0" normalizeH="0">
+          <a:defRPr kumimoji="0" sz="1800" b="0" i="0" u="none" strike="noStrike" cap="none" spc="0" normalizeH="0" baseline="0">
             <a:ln>
               <a:noFill/>
             </a:ln>
@@ -3331,7 +3447,7 @@
           <a:buFontTx/>
           <a:buNone/>
           <a:tabLst/>
-          <a:defRPr b="0" baseline="0" cap="none" i="0" spc="0" strike="noStrike" sz="1800" u="none" kumimoji="0" normalizeH="0">
+          <a:defRPr kumimoji="0" sz="1800" b="0" i="0" u="none" strike="noStrike" cap="none" spc="0" normalizeH="0" baseline="0">
             <a:ln>
               <a:noFill/>
             </a:ln>
@@ -3357,7 +3473,7 @@
           <a:buFontTx/>
           <a:buNone/>
           <a:tabLst/>
-          <a:defRPr b="0" baseline="0" cap="none" i="0" spc="0" strike="noStrike" sz="1800" u="none" kumimoji="0" normalizeH="0">
+          <a:defRPr kumimoji="0" sz="1800" b="0" i="0" u="none" strike="noStrike" cap="none" spc="0" normalizeH="0" baseline="0">
             <a:ln>
               <a:noFill/>
             </a:ln>
@@ -3383,7 +3499,7 @@
           <a:buFontTx/>
           <a:buNone/>
           <a:tabLst/>
-          <a:defRPr b="0" baseline="0" cap="none" i="0" spc="0" strike="noStrike" sz="1800" u="none" kumimoji="0" normalizeH="0">
+          <a:defRPr kumimoji="0" sz="1800" b="0" i="0" u="none" strike="noStrike" cap="none" spc="0" normalizeH="0" baseline="0">
             <a:ln>
               <a:noFill/>
             </a:ln>
@@ -3409,7 +3525,7 @@
           <a:buFontTx/>
           <a:buNone/>
           <a:tabLst/>
-          <a:defRPr b="0" baseline="0" cap="none" i="0" spc="0" strike="noStrike" sz="1800" u="none" kumimoji="0" normalizeH="0">
+          <a:defRPr kumimoji="0" sz="1800" b="0" i="0" u="none" strike="noStrike" cap="none" spc="0" normalizeH="0" baseline="0">
             <a:ln>
               <a:noFill/>
             </a:ln>
@@ -3435,7 +3551,7 @@
           <a:buFontTx/>
           <a:buNone/>
           <a:tabLst/>
-          <a:defRPr b="0" baseline="0" cap="none" i="0" spc="0" strike="noStrike" sz="1800" u="none" kumimoji="0" normalizeH="0">
+          <a:defRPr kumimoji="0" sz="1800" b="0" i="0" u="none" strike="noStrike" cap="none" spc="0" normalizeH="0" baseline="0">
             <a:ln>
               <a:noFill/>
             </a:ln>
@@ -3448,9 +3564,15 @@
         </a:lvl9pPr>
       </a:lstStyle>
       <a:style>
-        <a:lnRef idx="0"/>
-        <a:fillRef idx="0"/>
-        <a:effectRef idx="0"/>
+        <a:lnRef idx="0">
+          <a:scrgbClr r="0" g="0" b="0"/>
+        </a:lnRef>
+        <a:fillRef idx="0">
+          <a:scrgbClr r="0" g="0" b="0"/>
+        </a:fillRef>
+        <a:effectRef idx="0">
+          <a:scrgbClr r="0" g="0" b="0"/>
+        </a:effectRef>
         <a:fontRef idx="none"/>
       </a:style>
     </a:lnDef>
@@ -3464,7 +3586,7 @@
         <a:effectLst/>
         <a:sp3d/>
       </a:spPr>
-      <a:bodyPr rot="0" spcFirstLastPara="1" vertOverflow="overflow" horzOverflow="overflow" vert="horz" wrap="square" lIns="0" tIns="0" rIns="0" bIns="0" numCol="1" spcCol="38100" rtlCol="0" anchor="t" upright="0">
+      <a:bodyPr rot="0" spcFirstLastPara="1" vertOverflow="overflow" horzOverflow="overflow" vert="horz" wrap="square" lIns="0" tIns="0" rIns="0" bIns="0" numCol="1" spcCol="38100" rtlCol="0" anchor="t">
         <a:spAutoFit/>
       </a:bodyPr>
       <a:lstStyle>
@@ -3483,7 +3605,7 @@
           <a:buFontTx/>
           <a:buNone/>
           <a:tabLst/>
-          <a:defRPr b="0" baseline="0" cap="none" i="0" spc="0" strike="noStrike" sz="1400" u="none" kumimoji="0" normalizeH="0">
+          <a:defRPr kumimoji="0" sz="1400" b="0" i="0" u="none" strike="noStrike" cap="none" spc="0" normalizeH="0" baseline="0">
             <a:ln>
               <a:noFill/>
             </a:ln>
@@ -3513,7 +3635,7 @@
           <a:buFontTx/>
           <a:buNone/>
           <a:tabLst/>
-          <a:defRPr b="0" baseline="0" cap="none" i="0" spc="0" strike="noStrike" sz="1800" u="none" kumimoji="0" normalizeH="0">
+          <a:defRPr kumimoji="0" sz="1800" b="0" i="0" u="none" strike="noStrike" cap="none" spc="0" normalizeH="0" baseline="0">
             <a:ln>
               <a:noFill/>
             </a:ln>
@@ -3539,7 +3661,7 @@
           <a:buFontTx/>
           <a:buNone/>
           <a:tabLst/>
-          <a:defRPr b="0" baseline="0" cap="none" i="0" spc="0" strike="noStrike" sz="1800" u="none" kumimoji="0" normalizeH="0">
+          <a:defRPr kumimoji="0" sz="1800" b="0" i="0" u="none" strike="noStrike" cap="none" spc="0" normalizeH="0" baseline="0">
             <a:ln>
               <a:noFill/>
             </a:ln>
@@ -3565,7 +3687,7 @@
           <a:buFontTx/>
           <a:buNone/>
           <a:tabLst/>
-          <a:defRPr b="0" baseline="0" cap="none" i="0" spc="0" strike="noStrike" sz="1800" u="none" kumimoji="0" normalizeH="0">
+          <a:defRPr kumimoji="0" sz="1800" b="0" i="0" u="none" strike="noStrike" cap="none" spc="0" normalizeH="0" baseline="0">
             <a:ln>
               <a:noFill/>
             </a:ln>
@@ -3591,7 +3713,7 @@
           <a:buFontTx/>
           <a:buNone/>
           <a:tabLst/>
-          <a:defRPr b="0" baseline="0" cap="none" i="0" spc="0" strike="noStrike" sz="1800" u="none" kumimoji="0" normalizeH="0">
+          <a:defRPr kumimoji="0" sz="1800" b="0" i="0" u="none" strike="noStrike" cap="none" spc="0" normalizeH="0" baseline="0">
             <a:ln>
               <a:noFill/>
             </a:ln>
@@ -3617,7 +3739,7 @@
           <a:buFontTx/>
           <a:buNone/>
           <a:tabLst/>
-          <a:defRPr b="0" baseline="0" cap="none" i="0" spc="0" strike="noStrike" sz="1800" u="none" kumimoji="0" normalizeH="0">
+          <a:defRPr kumimoji="0" sz="1800" b="0" i="0" u="none" strike="noStrike" cap="none" spc="0" normalizeH="0" baseline="0">
             <a:ln>
               <a:noFill/>
             </a:ln>
@@ -3643,7 +3765,7 @@
           <a:buFontTx/>
           <a:buNone/>
           <a:tabLst/>
-          <a:defRPr b="0" baseline="0" cap="none" i="0" spc="0" strike="noStrike" sz="1800" u="none" kumimoji="0" normalizeH="0">
+          <a:defRPr kumimoji="0" sz="1800" b="0" i="0" u="none" strike="noStrike" cap="none" spc="0" normalizeH="0" baseline="0">
             <a:ln>
               <a:noFill/>
             </a:ln>
@@ -3669,7 +3791,7 @@
           <a:buFontTx/>
           <a:buNone/>
           <a:tabLst/>
-          <a:defRPr b="0" baseline="0" cap="none" i="0" spc="0" strike="noStrike" sz="1800" u="none" kumimoji="0" normalizeH="0">
+          <a:defRPr kumimoji="0" sz="1800" b="0" i="0" u="none" strike="noStrike" cap="none" spc="0" normalizeH="0" baseline="0">
             <a:ln>
               <a:noFill/>
             </a:ln>
@@ -3695,7 +3817,7 @@
           <a:buFontTx/>
           <a:buNone/>
           <a:tabLst/>
-          <a:defRPr b="0" baseline="0" cap="none" i="0" spc="0" strike="noStrike" sz="1800" u="none" kumimoji="0" normalizeH="0">
+          <a:defRPr kumimoji="0" sz="1800" b="0" i="0" u="none" strike="noStrike" cap="none" spc="0" normalizeH="0" baseline="0">
             <a:ln>
               <a:noFill/>
             </a:ln>
@@ -3721,7 +3843,7 @@
           <a:buFontTx/>
           <a:buNone/>
           <a:tabLst/>
-          <a:defRPr b="0" baseline="0" cap="none" i="0" spc="0" strike="noStrike" sz="1800" u="none" kumimoji="0" normalizeH="0">
+          <a:defRPr kumimoji="0" sz="1800" b="0" i="0" u="none" strike="noStrike" cap="none" spc="0" normalizeH="0" baseline="0">
             <a:ln>
               <a:noFill/>
             </a:ln>
@@ -3734,18 +3856,25 @@
         </a:lvl9pPr>
       </a:lstStyle>
       <a:style>
-        <a:lnRef idx="0"/>
-        <a:fillRef idx="0"/>
-        <a:effectRef idx="0"/>
+        <a:lnRef idx="0">
+          <a:scrgbClr r="0" g="0" b="0"/>
+        </a:lnRef>
+        <a:fillRef idx="0">
+          <a:scrgbClr r="0" g="0" b="0"/>
+        </a:fillRef>
+        <a:effectRef idx="0">
+          <a:scrgbClr r="0" g="0" b="0"/>
+        </a:effectRef>
         <a:fontRef idx="none"/>
       </a:style>
     </a:txDef>
   </a:objectDefaults>
+  <a:extraClrSchemeLst/>
 </a:theme>
 </file>
 
 <file path=ppt/theme/theme2.xml><?xml version="1.0" encoding="utf-8"?>
-<a:theme xmlns:a="http://schemas.openxmlformats.org/drawingml/2006/main" xmlns:r="http://schemas.openxmlformats.org/officeDocument/2006/relationships" name="佈景主題1">
+<a:theme xmlns:a="http://schemas.openxmlformats.org/drawingml/2006/main" name="佈景主題1">
   <a:themeElements>
     <a:clrScheme name="佈景主題1">
       <a:dk1>
@@ -3877,7 +4006,7 @@
         </a:effectStyle>
         <a:effectStyle>
           <a:effectLst>
-            <a:outerShdw sx="100000" sy="100000" kx="0" ky="0" algn="b" rotWithShape="0" blurRad="38100" dist="20000" dir="5400000">
+            <a:outerShdw blurRad="38100" dist="20000" dir="5400000" rotWithShape="0">
               <a:srgbClr val="000000">
                 <a:alpha val="38000"/>
               </a:srgbClr>
@@ -3953,7 +4082,7 @@
         <a:effectLst/>
         <a:sp3d/>
       </a:spPr>
-      <a:bodyPr rot="0" spcFirstLastPara="1" vertOverflow="overflow" horzOverflow="overflow" vert="horz" wrap="square" lIns="0" tIns="0" rIns="0" bIns="0" numCol="1" spcCol="38100" rtlCol="0" anchor="t" upright="0">
+      <a:bodyPr rot="0" spcFirstLastPara="1" vertOverflow="overflow" horzOverflow="overflow" vert="horz" wrap="square" lIns="0" tIns="0" rIns="0" bIns="0" numCol="1" spcCol="38100" rtlCol="0" anchor="t">
         <a:spAutoFit/>
       </a:bodyPr>
       <a:lstStyle>
@@ -3972,7 +4101,7 @@
           <a:buFontTx/>
           <a:buNone/>
           <a:tabLst/>
-          <a:defRPr b="0" baseline="0" cap="none" i="0" spc="0" strike="noStrike" sz="1400" u="none" kumimoji="0" normalizeH="0">
+          <a:defRPr kumimoji="0" sz="1400" b="0" i="0" u="none" strike="noStrike" cap="none" spc="0" normalizeH="0" baseline="0">
             <a:ln>
               <a:noFill/>
             </a:ln>
@@ -4002,7 +4131,7 @@
           <a:buFontTx/>
           <a:buNone/>
           <a:tabLst/>
-          <a:defRPr b="0" baseline="0" cap="none" i="0" spc="0" strike="noStrike" sz="1800" u="none" kumimoji="0" normalizeH="0">
+          <a:defRPr kumimoji="0" sz="1800" b="0" i="0" u="none" strike="noStrike" cap="none" spc="0" normalizeH="0" baseline="0">
             <a:ln>
               <a:noFill/>
             </a:ln>
@@ -4028,7 +4157,7 @@
           <a:buFontTx/>
           <a:buNone/>
           <a:tabLst/>
-          <a:defRPr b="0" baseline="0" cap="none" i="0" spc="0" strike="noStrike" sz="1800" u="none" kumimoji="0" normalizeH="0">
+          <a:defRPr kumimoji="0" sz="1800" b="0" i="0" u="none" strike="noStrike" cap="none" spc="0" normalizeH="0" baseline="0">
             <a:ln>
               <a:noFill/>
             </a:ln>
@@ -4054,7 +4183,7 @@
           <a:buFontTx/>
           <a:buNone/>
           <a:tabLst/>
-          <a:defRPr b="0" baseline="0" cap="none" i="0" spc="0" strike="noStrike" sz="1800" u="none" kumimoji="0" normalizeH="0">
+          <a:defRPr kumimoji="0" sz="1800" b="0" i="0" u="none" strike="noStrike" cap="none" spc="0" normalizeH="0" baseline="0">
             <a:ln>
               <a:noFill/>
             </a:ln>
@@ -4080,7 +4209,7 @@
           <a:buFontTx/>
           <a:buNone/>
           <a:tabLst/>
-          <a:defRPr b="0" baseline="0" cap="none" i="0" spc="0" strike="noStrike" sz="1800" u="none" kumimoji="0" normalizeH="0">
+          <a:defRPr kumimoji="0" sz="1800" b="0" i="0" u="none" strike="noStrike" cap="none" spc="0" normalizeH="0" baseline="0">
             <a:ln>
               <a:noFill/>
             </a:ln>
@@ -4106,7 +4235,7 @@
           <a:buFontTx/>
           <a:buNone/>
           <a:tabLst/>
-          <a:defRPr b="0" baseline="0" cap="none" i="0" spc="0" strike="noStrike" sz="1800" u="none" kumimoji="0" normalizeH="0">
+          <a:defRPr kumimoji="0" sz="1800" b="0" i="0" u="none" strike="noStrike" cap="none" spc="0" normalizeH="0" baseline="0">
             <a:ln>
               <a:noFill/>
             </a:ln>
@@ -4132,7 +4261,7 @@
           <a:buFontTx/>
           <a:buNone/>
           <a:tabLst/>
-          <a:defRPr b="0" baseline="0" cap="none" i="0" spc="0" strike="noStrike" sz="1800" u="none" kumimoji="0" normalizeH="0">
+          <a:defRPr kumimoji="0" sz="1800" b="0" i="0" u="none" strike="noStrike" cap="none" spc="0" normalizeH="0" baseline="0">
             <a:ln>
               <a:noFill/>
             </a:ln>
@@ -4158,7 +4287,7 @@
           <a:buFontTx/>
           <a:buNone/>
           <a:tabLst/>
-          <a:defRPr b="0" baseline="0" cap="none" i="0" spc="0" strike="noStrike" sz="1800" u="none" kumimoji="0" normalizeH="0">
+          <a:defRPr kumimoji="0" sz="1800" b="0" i="0" u="none" strike="noStrike" cap="none" spc="0" normalizeH="0" baseline="0">
             <a:ln>
               <a:noFill/>
             </a:ln>
@@ -4184,7 +4313,7 @@
           <a:buFontTx/>
           <a:buNone/>
           <a:tabLst/>
-          <a:defRPr b="0" baseline="0" cap="none" i="0" spc="0" strike="noStrike" sz="1800" u="none" kumimoji="0" normalizeH="0">
+          <a:defRPr kumimoji="0" sz="1800" b="0" i="0" u="none" strike="noStrike" cap="none" spc="0" normalizeH="0" baseline="0">
             <a:ln>
               <a:noFill/>
             </a:ln>
@@ -4210,7 +4339,7 @@
           <a:buFontTx/>
           <a:buNone/>
           <a:tabLst/>
-          <a:defRPr b="0" baseline="0" cap="none" i="0" spc="0" strike="noStrike" sz="1800" u="none" kumimoji="0" normalizeH="0">
+          <a:defRPr kumimoji="0" sz="1800" b="0" i="0" u="none" strike="noStrike" cap="none" spc="0" normalizeH="0" baseline="0">
             <a:ln>
               <a:noFill/>
             </a:ln>
@@ -4223,9 +4352,15 @@
         </a:lvl9pPr>
       </a:lstStyle>
       <a:style>
-        <a:lnRef idx="0"/>
-        <a:fillRef idx="0"/>
-        <a:effectRef idx="0"/>
+        <a:lnRef idx="0">
+          <a:scrgbClr r="0" g="0" b="0"/>
+        </a:lnRef>
+        <a:fillRef idx="0">
+          <a:scrgbClr r="0" g="0" b="0"/>
+        </a:fillRef>
+        <a:effectRef idx="0">
+          <a:scrgbClr r="0" g="0" b="0"/>
+        </a:effectRef>
         <a:fontRef idx="none"/>
       </a:style>
     </a:spDef>
@@ -4240,7 +4375,7 @@
           <a:round/>
         </a:ln>
         <a:effectLst>
-          <a:outerShdw sx="100000" sy="100000" kx="0" ky="0" algn="b" rotWithShape="0" blurRad="38100" dist="20000" dir="5400000">
+          <a:outerShdw blurRad="38100" dist="20000" dir="5400000" rotWithShape="0">
             <a:srgbClr val="000000">
               <a:alpha val="38000"/>
             </a:srgbClr>
@@ -4248,7 +4383,7 @@
         </a:effectLst>
         <a:sp3d/>
       </a:spPr>
-      <a:bodyPr rot="0" spcFirstLastPara="1" vertOverflow="overflow" horzOverflow="overflow" vert="horz" wrap="square" lIns="91439" tIns="45719" rIns="91439" bIns="45719" numCol="1" spcCol="38100" rtlCol="0" anchor="t" upright="0">
+      <a:bodyPr rot="0" spcFirstLastPara="1" vertOverflow="overflow" horzOverflow="overflow" vert="horz" wrap="square" lIns="91439" tIns="45719" rIns="91439" bIns="45719" numCol="1" spcCol="38100" rtlCol="0" anchor="t">
         <a:noAutofit/>
       </a:bodyPr>
       <a:lstStyle>
@@ -4267,7 +4402,7 @@
           <a:buFontTx/>
           <a:buNone/>
           <a:tabLst/>
-          <a:defRPr b="0" baseline="0" cap="none" i="0" spc="0" strike="noStrike" sz="1800" u="none" kumimoji="0" normalizeH="0">
+          <a:defRPr kumimoji="0" sz="1800" b="0" i="0" u="none" strike="noStrike" cap="none" spc="0" normalizeH="0" baseline="0">
             <a:ln>
               <a:noFill/>
             </a:ln>
@@ -4293,7 +4428,7 @@
           <a:buFontTx/>
           <a:buNone/>
           <a:tabLst/>
-          <a:defRPr b="0" baseline="0" cap="none" i="0" spc="0" strike="noStrike" sz="1800" u="none" kumimoji="0" normalizeH="0">
+          <a:defRPr kumimoji="0" sz="1800" b="0" i="0" u="none" strike="noStrike" cap="none" spc="0" normalizeH="0" baseline="0">
             <a:ln>
               <a:noFill/>
             </a:ln>
@@ -4319,7 +4454,7 @@
           <a:buFontTx/>
           <a:buNone/>
           <a:tabLst/>
-          <a:defRPr b="0" baseline="0" cap="none" i="0" spc="0" strike="noStrike" sz="1800" u="none" kumimoji="0" normalizeH="0">
+          <a:defRPr kumimoji="0" sz="1800" b="0" i="0" u="none" strike="noStrike" cap="none" spc="0" normalizeH="0" baseline="0">
             <a:ln>
               <a:noFill/>
             </a:ln>
@@ -4345,7 +4480,7 @@
           <a:buFontTx/>
           <a:buNone/>
           <a:tabLst/>
-          <a:defRPr b="0" baseline="0" cap="none" i="0" spc="0" strike="noStrike" sz="1800" u="none" kumimoji="0" normalizeH="0">
+          <a:defRPr kumimoji="0" sz="1800" b="0" i="0" u="none" strike="noStrike" cap="none" spc="0" normalizeH="0" baseline="0">
             <a:ln>
               <a:noFill/>
             </a:ln>
@@ -4371,7 +4506,7 @@
           <a:buFontTx/>
           <a:buNone/>
           <a:tabLst/>
-          <a:defRPr b="0" baseline="0" cap="none" i="0" spc="0" strike="noStrike" sz="1800" u="none" kumimoji="0" normalizeH="0">
+          <a:defRPr kumimoji="0" sz="1800" b="0" i="0" u="none" strike="noStrike" cap="none" spc="0" normalizeH="0" baseline="0">
             <a:ln>
               <a:noFill/>
             </a:ln>
@@ -4397,7 +4532,7 @@
           <a:buFontTx/>
           <a:buNone/>
           <a:tabLst/>
-          <a:defRPr b="0" baseline="0" cap="none" i="0" spc="0" strike="noStrike" sz="1800" u="none" kumimoji="0" normalizeH="0">
+          <a:defRPr kumimoji="0" sz="1800" b="0" i="0" u="none" strike="noStrike" cap="none" spc="0" normalizeH="0" baseline="0">
             <a:ln>
               <a:noFill/>
             </a:ln>
@@ -4423,7 +4558,7 @@
           <a:buFontTx/>
           <a:buNone/>
           <a:tabLst/>
-          <a:defRPr b="0" baseline="0" cap="none" i="0" spc="0" strike="noStrike" sz="1800" u="none" kumimoji="0" normalizeH="0">
+          <a:defRPr kumimoji="0" sz="1800" b="0" i="0" u="none" strike="noStrike" cap="none" spc="0" normalizeH="0" baseline="0">
             <a:ln>
               <a:noFill/>
             </a:ln>
@@ -4449,7 +4584,7 @@
           <a:buFontTx/>
           <a:buNone/>
           <a:tabLst/>
-          <a:defRPr b="0" baseline="0" cap="none" i="0" spc="0" strike="noStrike" sz="1800" u="none" kumimoji="0" normalizeH="0">
+          <a:defRPr kumimoji="0" sz="1800" b="0" i="0" u="none" strike="noStrike" cap="none" spc="0" normalizeH="0" baseline="0">
             <a:ln>
               <a:noFill/>
             </a:ln>
@@ -4475,7 +4610,7 @@
           <a:buFontTx/>
           <a:buNone/>
           <a:tabLst/>
-          <a:defRPr b="0" baseline="0" cap="none" i="0" spc="0" strike="noStrike" sz="1800" u="none" kumimoji="0" normalizeH="0">
+          <a:defRPr kumimoji="0" sz="1800" b="0" i="0" u="none" strike="noStrike" cap="none" spc="0" normalizeH="0" baseline="0">
             <a:ln>
               <a:noFill/>
             </a:ln>
@@ -4501,7 +4636,7 @@
           <a:buFontTx/>
           <a:buNone/>
           <a:tabLst/>
-          <a:defRPr b="0" baseline="0" cap="none" i="0" spc="0" strike="noStrike" sz="1800" u="none" kumimoji="0" normalizeH="0">
+          <a:defRPr kumimoji="0" sz="1800" b="0" i="0" u="none" strike="noStrike" cap="none" spc="0" normalizeH="0" baseline="0">
             <a:ln>
               <a:noFill/>
             </a:ln>
@@ -4514,9 +4649,15 @@
         </a:lvl9pPr>
       </a:lstStyle>
       <a:style>
-        <a:lnRef idx="0"/>
-        <a:fillRef idx="0"/>
-        <a:effectRef idx="0"/>
+        <a:lnRef idx="0">
+          <a:scrgbClr r="0" g="0" b="0"/>
+        </a:lnRef>
+        <a:fillRef idx="0">
+          <a:scrgbClr r="0" g="0" b="0"/>
+        </a:fillRef>
+        <a:effectRef idx="0">
+          <a:scrgbClr r="0" g="0" b="0"/>
+        </a:effectRef>
         <a:fontRef idx="none"/>
       </a:style>
     </a:lnDef>
@@ -4530,7 +4671,7 @@
         <a:effectLst/>
         <a:sp3d/>
       </a:spPr>
-      <a:bodyPr rot="0" spcFirstLastPara="1" vertOverflow="overflow" horzOverflow="overflow" vert="horz" wrap="square" lIns="0" tIns="0" rIns="0" bIns="0" numCol="1" spcCol="38100" rtlCol="0" anchor="t" upright="0">
+      <a:bodyPr rot="0" spcFirstLastPara="1" vertOverflow="overflow" horzOverflow="overflow" vert="horz" wrap="square" lIns="0" tIns="0" rIns="0" bIns="0" numCol="1" spcCol="38100" rtlCol="0" anchor="t">
         <a:spAutoFit/>
       </a:bodyPr>
       <a:lstStyle>
@@ -4549,7 +4690,7 @@
           <a:buFontTx/>
           <a:buNone/>
           <a:tabLst/>
-          <a:defRPr b="0" baseline="0" cap="none" i="0" spc="0" strike="noStrike" sz="1400" u="none" kumimoji="0" normalizeH="0">
+          <a:defRPr kumimoji="0" sz="1400" b="0" i="0" u="none" strike="noStrike" cap="none" spc="0" normalizeH="0" baseline="0">
             <a:ln>
               <a:noFill/>
             </a:ln>
@@ -4579,7 +4720,7 @@
           <a:buFontTx/>
           <a:buNone/>
           <a:tabLst/>
-          <a:defRPr b="0" baseline="0" cap="none" i="0" spc="0" strike="noStrike" sz="1800" u="none" kumimoji="0" normalizeH="0">
+          <a:defRPr kumimoji="0" sz="1800" b="0" i="0" u="none" strike="noStrike" cap="none" spc="0" normalizeH="0" baseline="0">
             <a:ln>
               <a:noFill/>
             </a:ln>
@@ -4605,7 +4746,7 @@
           <a:buFontTx/>
           <a:buNone/>
           <a:tabLst/>
-          <a:defRPr b="0" baseline="0" cap="none" i="0" spc="0" strike="noStrike" sz="1800" u="none" kumimoji="0" normalizeH="0">
+          <a:defRPr kumimoji="0" sz="1800" b="0" i="0" u="none" strike="noStrike" cap="none" spc="0" normalizeH="0" baseline="0">
             <a:ln>
               <a:noFill/>
             </a:ln>
@@ -4631,7 +4772,7 @@
           <a:buFontTx/>
           <a:buNone/>
           <a:tabLst/>
-          <a:defRPr b="0" baseline="0" cap="none" i="0" spc="0" strike="noStrike" sz="1800" u="none" kumimoji="0" normalizeH="0">
+          <a:defRPr kumimoji="0" sz="1800" b="0" i="0" u="none" strike="noStrike" cap="none" spc="0" normalizeH="0" baseline="0">
             <a:ln>
               <a:noFill/>
             </a:ln>
@@ -4657,7 +4798,7 @@
           <a:buFontTx/>
           <a:buNone/>
           <a:tabLst/>
-          <a:defRPr b="0" baseline="0" cap="none" i="0" spc="0" strike="noStrike" sz="1800" u="none" kumimoji="0" normalizeH="0">
+          <a:defRPr kumimoji="0" sz="1800" b="0" i="0" u="none" strike="noStrike" cap="none" spc="0" normalizeH="0" baseline="0">
             <a:ln>
               <a:noFill/>
             </a:ln>
@@ -4683,7 +4824,7 @@
           <a:buFontTx/>
           <a:buNone/>
           <a:tabLst/>
-          <a:defRPr b="0" baseline="0" cap="none" i="0" spc="0" strike="noStrike" sz="1800" u="none" kumimoji="0" normalizeH="0">
+          <a:defRPr kumimoji="0" sz="1800" b="0" i="0" u="none" strike="noStrike" cap="none" spc="0" normalizeH="0" baseline="0">
             <a:ln>
               <a:noFill/>
             </a:ln>
@@ -4709,7 +4850,7 @@
           <a:buFontTx/>
           <a:buNone/>
           <a:tabLst/>
-          <a:defRPr b="0" baseline="0" cap="none" i="0" spc="0" strike="noStrike" sz="1800" u="none" kumimoji="0" normalizeH="0">
+          <a:defRPr kumimoji="0" sz="1800" b="0" i="0" u="none" strike="noStrike" cap="none" spc="0" normalizeH="0" baseline="0">
             <a:ln>
               <a:noFill/>
             </a:ln>
@@ -4735,7 +4876,7 @@
           <a:buFontTx/>
           <a:buNone/>
           <a:tabLst/>
-          <a:defRPr b="0" baseline="0" cap="none" i="0" spc="0" strike="noStrike" sz="1800" u="none" kumimoji="0" normalizeH="0">
+          <a:defRPr kumimoji="0" sz="1800" b="0" i="0" u="none" strike="noStrike" cap="none" spc="0" normalizeH="0" baseline="0">
             <a:ln>
               <a:noFill/>
             </a:ln>
@@ -4761,7 +4902,7 @@
           <a:buFontTx/>
           <a:buNone/>
           <a:tabLst/>
-          <a:defRPr b="0" baseline="0" cap="none" i="0" spc="0" strike="noStrike" sz="1800" u="none" kumimoji="0" normalizeH="0">
+          <a:defRPr kumimoji="0" sz="1800" b="0" i="0" u="none" strike="noStrike" cap="none" spc="0" normalizeH="0" baseline="0">
             <a:ln>
               <a:noFill/>
             </a:ln>
@@ -4787,7 +4928,7 @@
           <a:buFontTx/>
           <a:buNone/>
           <a:tabLst/>
-          <a:defRPr b="0" baseline="0" cap="none" i="0" spc="0" strike="noStrike" sz="1800" u="none" kumimoji="0" normalizeH="0">
+          <a:defRPr kumimoji="0" sz="1800" b="0" i="0" u="none" strike="noStrike" cap="none" spc="0" normalizeH="0" baseline="0">
             <a:ln>
               <a:noFill/>
             </a:ln>
@@ -4800,12 +4941,19 @@
         </a:lvl9pPr>
       </a:lstStyle>
       <a:style>
-        <a:lnRef idx="0"/>
-        <a:fillRef idx="0"/>
-        <a:effectRef idx="0"/>
+        <a:lnRef idx="0">
+          <a:scrgbClr r="0" g="0" b="0"/>
+        </a:lnRef>
+        <a:fillRef idx="0">
+          <a:scrgbClr r="0" g="0" b="0"/>
+        </a:fillRef>
+        <a:effectRef idx="0">
+          <a:scrgbClr r="0" g="0" b="0"/>
+        </a:effectRef>
         <a:fontRef idx="none"/>
       </a:style>
     </a:txDef>
   </a:objectDefaults>
+  <a:extraClrSchemeLst/>
 </a:theme>
 </file>
</xml_diff>